<commit_message>
add aula sobre idiomas de programacao
</commit_message>
<xml_diff>
--- a/aulas/gsi526/aula13-idiomas-programacao.pptx
+++ b/aulas/gsi526/aula13-idiomas-programacao.pptx
@@ -5,7 +5,7 @@
     <p:sldMasterId id="2147483659" r:id="rId1"/>
   </p:sldMasterIdLst>
   <p:notesMasterIdLst>
-    <p:notesMasterId r:id="rId27"/>
+    <p:notesMasterId r:id="rId23"/>
   </p:notesMasterIdLst>
   <p:sldIdLst>
     <p:sldId id="256" r:id="rId2"/>
@@ -20,19 +20,15 @@
     <p:sldId id="336" r:id="rId11"/>
     <p:sldId id="337" r:id="rId12"/>
     <p:sldId id="338" r:id="rId13"/>
-    <p:sldId id="310" r:id="rId14"/>
-    <p:sldId id="339" r:id="rId15"/>
-    <p:sldId id="340" r:id="rId16"/>
-    <p:sldId id="341" r:id="rId17"/>
-    <p:sldId id="342" r:id="rId18"/>
-    <p:sldId id="343" r:id="rId19"/>
-    <p:sldId id="344" r:id="rId20"/>
-    <p:sldId id="345" r:id="rId21"/>
-    <p:sldId id="346" r:id="rId22"/>
-    <p:sldId id="347" r:id="rId23"/>
-    <p:sldId id="348" r:id="rId24"/>
-    <p:sldId id="349" r:id="rId25"/>
-    <p:sldId id="328" r:id="rId26"/>
+    <p:sldId id="339" r:id="rId14"/>
+    <p:sldId id="340" r:id="rId15"/>
+    <p:sldId id="341" r:id="rId16"/>
+    <p:sldId id="342" r:id="rId17"/>
+    <p:sldId id="343" r:id="rId18"/>
+    <p:sldId id="344" r:id="rId19"/>
+    <p:sldId id="345" r:id="rId20"/>
+    <p:sldId id="346" r:id="rId21"/>
+    <p:sldId id="347" r:id="rId22"/>
   </p:sldIdLst>
   <p:sldSz cx="9144000" cy="5143500" type="screen16x9"/>
   <p:notesSz cx="6858000" cy="9144000"/>
@@ -5631,7 +5627,7 @@
             </a:pPr>
             <a:r>
               <a:rPr lang="pt-BR" b="1" dirty="0" smtClean="0"/>
-              <a:t>Controle de Versão</a:t>
+              <a:t>Idiomas de Programação</a:t>
             </a:r>
             <a:endParaRPr b="1" dirty="0"/>
           </a:p>
@@ -5736,8 +5732,8 @@
         </p:nvSpPr>
         <p:spPr>
           <a:xfrm>
-            <a:off x="326640" y="4645094"/>
-            <a:ext cx="4245360" cy="429845"/>
+            <a:off x="444402" y="4626972"/>
+            <a:ext cx="5097415" cy="429845"/>
           </a:xfrm>
           <a:prstGeom prst="rect">
             <a:avLst/>
@@ -5990,6 +5986,10 @@
               </a:spcAft>
               <a:buNone/>
             </a:pPr>
+            <a:r>
+              <a:rPr lang="pt-BR" sz="1600" dirty="0" smtClean="0"/>
+              <a:t>Slides do prof. Eduardo Figueiredo do DCC/UFMG</a:t>
+            </a:r>
             <a:endParaRPr sz="1600" dirty="0"/>
           </a:p>
         </p:txBody>
@@ -6031,7 +6031,7 @@
         </p:nvSpPr>
         <p:spPr>
           <a:xfrm>
-            <a:off x="311700" y="251061"/>
+            <a:off x="311700" y="246254"/>
             <a:ext cx="8520600" cy="572700"/>
           </a:xfrm>
         </p:spPr>
@@ -6042,7 +6042,7 @@
             <a:pPr algn="ctr"/>
             <a:r>
               <a:rPr lang="pt-BR" dirty="0" smtClean="0"/>
-              <a:t>SCV Distribuído</a:t>
+              <a:t>Convenção de Nomes</a:t>
             </a:r>
             <a:endParaRPr lang="pt-BR" dirty="0"/>
           </a:p>
@@ -6058,32 +6058,45 @@
             <p:ph type="body" idx="1"/>
           </p:nvPr>
         </p:nvSpPr>
-        <p:spPr>
-          <a:xfrm>
-            <a:off x="311700" y="1018021"/>
-            <a:ext cx="8520600" cy="3904342"/>
-          </a:xfrm>
-        </p:spPr>
+        <p:spPr/>
         <p:txBody>
           <a:bodyPr/>
           <a:lstStyle/>
           <a:p>
             <a:r>
               <a:rPr lang="pt-BR" sz="2000" dirty="0" smtClean="0"/>
-              <a:t>Por ser na própria máquina, o SCV distribuído acaba sendo mais rápido, porém exige maior conhecimento da ferramenta</a:t>
-            </a:r>
-          </a:p>
-          <a:p>
-            <a:endParaRPr lang="pt-BR" sz="2000" dirty="0"/>
-          </a:p>
-          <a:p>
+              <a:t>Deve-se usar </a:t>
+            </a:r>
+            <a:r>
+              <a:rPr lang="pt-BR" sz="2000" i="1" dirty="0" smtClean="0"/>
+              <a:t>camel case </a:t>
+            </a:r>
             <a:r>
               <a:rPr lang="pt-BR" sz="2000" dirty="0" smtClean="0"/>
-              <a:t>Portanto, por esse tratamento de mesclagem ser diferente, podem ocorrer situações onde o trabalho de alguém possa ser sobreposto e gerar tormento para os demais desenvolvedores</a:t>
-            </a:r>
-          </a:p>
-          <a:p>
-            <a:endParaRPr lang="pt-BR" sz="2000" dirty="0"/>
+              <a:t>em nomes de classes, métodos e atributos</a:t>
+            </a:r>
+          </a:p>
+          <a:p>
+            <a:pPr lvl="1"/>
+            <a:r>
+              <a:rPr lang="pt-BR" sz="1800" dirty="0" smtClean="0"/>
+              <a:t>Nome de classes deve ser um substantivo e iniciar com letra maiúscula</a:t>
+            </a:r>
+          </a:p>
+          <a:p>
+            <a:pPr lvl="1"/>
+            <a:r>
+              <a:rPr lang="pt-BR" sz="1800" dirty="0" smtClean="0"/>
+              <a:t>Nome de métodos deve ser um verbo e iniciar com letra minúscula</a:t>
+            </a:r>
+          </a:p>
+          <a:p>
+            <a:pPr lvl="1"/>
+            <a:r>
+              <a:rPr lang="pt-BR" sz="1800" dirty="0" smtClean="0"/>
+              <a:t>Nome de atributos deve ser um adjetivo ou substantivo e iniciar com letra minúscula</a:t>
+            </a:r>
+            <a:endParaRPr lang="pt-BR" sz="1800" dirty="0"/>
           </a:p>
         </p:txBody>
       </p:sp>
@@ -6141,8 +6154,8 @@
         </p:blipFill>
         <p:spPr>
           <a:xfrm>
-            <a:off x="924287" y="3557895"/>
-            <a:ext cx="2906496" cy="1305204"/>
+            <a:off x="311700" y="1714473"/>
+            <a:ext cx="615524" cy="488967"/>
           </a:xfrm>
           <a:prstGeom prst="rect">
             <a:avLst/>
@@ -6171,8 +6184,38 @@
         </p:blipFill>
         <p:spPr>
           <a:xfrm>
-            <a:off x="4443370" y="3523557"/>
-            <a:ext cx="1202357" cy="1422684"/>
+            <a:off x="289014" y="2271979"/>
+            <a:ext cx="615372" cy="493459"/>
+          </a:xfrm>
+          <a:prstGeom prst="rect">
+            <a:avLst/>
+          </a:prstGeom>
+        </p:spPr>
+      </p:pic>
+      <p:pic>
+        <p:nvPicPr>
+          <p:cNvPr id="7" name="Picture 6"/>
+          <p:cNvPicPr>
+            <a:picLocks noChangeAspect="1"/>
+          </p:cNvPicPr>
+          <p:nvPr/>
+        </p:nvPicPr>
+        <p:blipFill>
+          <a:blip r:embed="rId4">
+            <a:extLst>
+              <a:ext uri="{28A0092B-C50C-407E-A947-70E740481C1C}">
+                <a14:useLocalDpi xmlns:a14="http://schemas.microsoft.com/office/drawing/2010/main" val="0"/>
+              </a:ext>
+            </a:extLst>
+          </a:blip>
+          <a:stretch>
+            <a:fillRect/>
+          </a:stretch>
+        </p:blipFill>
+        <p:spPr>
+          <a:xfrm>
+            <a:off x="289014" y="2833059"/>
+            <a:ext cx="646621" cy="531800"/>
           </a:xfrm>
           <a:prstGeom prst="rect">
             <a:avLst/>
@@ -6182,7 +6225,7 @@
     </p:spTree>
     <p:extLst>
       <p:ext uri="{BB962C8B-B14F-4D97-AF65-F5344CB8AC3E}">
-        <p14:creationId xmlns:p14="http://schemas.microsoft.com/office/powerpoint/2010/main" val="2865552315"/>
+        <p14:creationId xmlns:p14="http://schemas.microsoft.com/office/powerpoint/2010/main" val="2467976823"/>
       </p:ext>
     </p:extLst>
   </p:cSld>
@@ -6232,7 +6275,7 @@
             <a:pPr algn="ctr"/>
             <a:r>
               <a:rPr lang="pt-BR" dirty="0" smtClean="0"/>
-              <a:t>Vantagens de um SCV</a:t>
+              <a:t>Indentação e Comentários</a:t>
             </a:r>
             <a:endParaRPr lang="pt-BR" dirty="0"/>
           </a:p>
@@ -6253,79 +6296,27 @@
           <a:bodyPr/>
           <a:lstStyle/>
           <a:p>
-            <a:pPr>
-              <a:lnSpc>
-                <a:spcPct val="100000"/>
-              </a:lnSpc>
-            </a:pPr>
             <a:r>
               <a:rPr lang="pt-BR" sz="2000" dirty="0" smtClean="0"/>
-              <a:t>Histórico</a:t>
-            </a:r>
-            <a:endParaRPr lang="pt-BR" dirty="0" smtClean="0"/>
-          </a:p>
-          <a:p>
-            <a:pPr lvl="1">
-              <a:lnSpc>
-                <a:spcPct val="100000"/>
-              </a:lnSpc>
-            </a:pPr>
-            <a:r>
-              <a:rPr lang="pt-BR" sz="1600" dirty="0" smtClean="0"/>
-              <a:t>Registra toda a evolução do projeto, cada alteração sobre cada arquivo</a:t>
-            </a:r>
-          </a:p>
-          <a:p>
-            <a:endParaRPr lang="pt-BR" dirty="0"/>
-          </a:p>
-          <a:p>
-            <a:pPr>
-              <a:lnSpc>
-                <a:spcPct val="100000"/>
-              </a:lnSpc>
-            </a:pPr>
+              <a:t>Evidencie o aninhamento de estruturas por meio de indentação</a:t>
+            </a:r>
+          </a:p>
+          <a:p>
+            <a:endParaRPr lang="pt-BR" sz="2000" dirty="0"/>
+          </a:p>
+          <a:p>
             <a:r>
               <a:rPr lang="pt-BR" sz="2000" dirty="0" smtClean="0"/>
-              <a:t>Colaboração</a:t>
-            </a:r>
-            <a:endParaRPr lang="pt-BR" dirty="0" smtClean="0"/>
-          </a:p>
-          <a:p>
-            <a:pPr lvl="1">
-              <a:lnSpc>
-                <a:spcPct val="100000"/>
-              </a:lnSpc>
-            </a:pPr>
-            <a:r>
-              <a:rPr lang="pt-BR" sz="1600" dirty="0" smtClean="0"/>
-              <a:t>Possibilita que vários desenvolvedores trabalhem em paralelo sobre os mesmos arquivos</a:t>
-            </a:r>
-          </a:p>
-          <a:p>
-            <a:endParaRPr lang="pt-BR" dirty="0"/>
-          </a:p>
-          <a:p>
-            <a:pPr>
-              <a:lnSpc>
-                <a:spcPct val="100000"/>
-              </a:lnSpc>
-            </a:pPr>
-            <a:r>
-              <a:rPr lang="pt-BR" sz="2000" dirty="0" smtClean="0"/>
-              <a:t>Variações no projeto</a:t>
-            </a:r>
-          </a:p>
-          <a:p>
-            <a:pPr lvl="1">
-              <a:lnSpc>
-                <a:spcPct val="100000"/>
-              </a:lnSpc>
-            </a:pPr>
-            <a:r>
-              <a:rPr lang="pt-BR" sz="1600" dirty="0" smtClean="0"/>
-              <a:t>Mantém linhas diferentes de evolução do projeto</a:t>
-            </a:r>
-            <a:endParaRPr lang="pt-BR" sz="1600" dirty="0"/>
+              <a:t>Separar por uma linha em branco a primeira linha de um bloco de comentários da última linha do bloco de comandos que o antecede</a:t>
+            </a:r>
+          </a:p>
+          <a:p>
+            <a:pPr lvl="1"/>
+            <a:r>
+              <a:rPr lang="pt-BR" sz="1800" dirty="0" smtClean="0"/>
+              <a:t>Comentários devem se referir ao código que segue</a:t>
+            </a:r>
+            <a:endParaRPr lang="pt-BR" sz="1800" dirty="0"/>
           </a:p>
         </p:txBody>
       </p:sp>
@@ -6361,10 +6352,100 @@
           </a:p>
         </p:txBody>
       </p:sp>
+      <p:pic>
+        <p:nvPicPr>
+          <p:cNvPr id="5" name="Picture 4"/>
+          <p:cNvPicPr>
+            <a:picLocks noChangeAspect="1"/>
+          </p:cNvPicPr>
+          <p:nvPr/>
+        </p:nvPicPr>
+        <p:blipFill>
+          <a:blip r:embed="rId2">
+            <a:extLst>
+              <a:ext uri="{28A0092B-C50C-407E-A947-70E740481C1C}">
+                <a14:useLocalDpi xmlns:a14="http://schemas.microsoft.com/office/drawing/2010/main" val="0"/>
+              </a:ext>
+            </a:extLst>
+          </a:blip>
+          <a:stretch>
+            <a:fillRect/>
+          </a:stretch>
+        </p:blipFill>
+        <p:spPr>
+          <a:xfrm>
+            <a:off x="8079678" y="1152476"/>
+            <a:ext cx="614050" cy="509778"/>
+          </a:xfrm>
+          <a:prstGeom prst="rect">
+            <a:avLst/>
+          </a:prstGeom>
+        </p:spPr>
+      </p:pic>
+      <p:pic>
+        <p:nvPicPr>
+          <p:cNvPr id="6" name="Picture 5"/>
+          <p:cNvPicPr>
+            <a:picLocks noChangeAspect="1"/>
+          </p:cNvPicPr>
+          <p:nvPr/>
+        </p:nvPicPr>
+        <p:blipFill>
+          <a:blip r:embed="rId3">
+            <a:extLst>
+              <a:ext uri="{28A0092B-C50C-407E-A947-70E740481C1C}">
+                <a14:useLocalDpi xmlns:a14="http://schemas.microsoft.com/office/drawing/2010/main" val="0"/>
+              </a:ext>
+            </a:extLst>
+          </a:blip>
+          <a:stretch>
+            <a:fillRect/>
+          </a:stretch>
+        </p:blipFill>
+        <p:spPr>
+          <a:xfrm>
+            <a:off x="8398238" y="1939208"/>
+            <a:ext cx="622919" cy="504268"/>
+          </a:xfrm>
+          <a:prstGeom prst="rect">
+            <a:avLst/>
+          </a:prstGeom>
+        </p:spPr>
+      </p:pic>
+      <p:pic>
+        <p:nvPicPr>
+          <p:cNvPr id="7" name="Picture 6"/>
+          <p:cNvPicPr>
+            <a:picLocks noChangeAspect="1"/>
+          </p:cNvPicPr>
+          <p:nvPr/>
+        </p:nvPicPr>
+        <p:blipFill>
+          <a:blip r:embed="rId4">
+            <a:extLst>
+              <a:ext uri="{28A0092B-C50C-407E-A947-70E740481C1C}">
+                <a14:useLocalDpi xmlns:a14="http://schemas.microsoft.com/office/drawing/2010/main" val="0"/>
+              </a:ext>
+            </a:extLst>
+          </a:blip>
+          <a:stretch>
+            <a:fillRect/>
+          </a:stretch>
+        </p:blipFill>
+        <p:spPr>
+          <a:xfrm>
+            <a:off x="6605811" y="2708189"/>
+            <a:ext cx="653971" cy="520755"/>
+          </a:xfrm>
+          <a:prstGeom prst="rect">
+            <a:avLst/>
+          </a:prstGeom>
+        </p:spPr>
+      </p:pic>
     </p:spTree>
     <p:extLst>
       <p:ext uri="{BB962C8B-B14F-4D97-AF65-F5344CB8AC3E}">
-        <p14:creationId xmlns:p14="http://schemas.microsoft.com/office/powerpoint/2010/main" val="3973803911"/>
+        <p14:creationId xmlns:p14="http://schemas.microsoft.com/office/powerpoint/2010/main" val="3783571812"/>
       </p:ext>
     </p:extLst>
   </p:cSld>
@@ -6403,7 +6484,7 @@
         </p:nvSpPr>
         <p:spPr>
           <a:xfrm>
-            <a:off x="297846" y="167934"/>
+            <a:off x="304773" y="216425"/>
             <a:ext cx="8520600" cy="572700"/>
           </a:xfrm>
         </p:spPr>
@@ -6414,7 +6495,7 @@
             <a:pPr algn="ctr"/>
             <a:r>
               <a:rPr lang="pt-BR" dirty="0" smtClean="0"/>
-              <a:t>Histórico dos SCVs</a:t>
+              <a:t>Exemplo: Carro 2</a:t>
             </a:r>
             <a:endParaRPr lang="pt-BR" dirty="0"/>
           </a:p>
@@ -6474,8 +6555,8 @@
         </p:blipFill>
         <p:spPr>
           <a:xfrm>
-            <a:off x="1816611" y="907755"/>
-            <a:ext cx="4404080" cy="4079789"/>
+            <a:off x="777321" y="1011384"/>
+            <a:ext cx="6350843" cy="3917906"/>
           </a:xfrm>
           <a:prstGeom prst="rect">
             <a:avLst/>
@@ -6485,7 +6566,7 @@
     </p:spTree>
     <p:extLst>
       <p:ext uri="{BB962C8B-B14F-4D97-AF65-F5344CB8AC3E}">
-        <p14:creationId xmlns:p14="http://schemas.microsoft.com/office/powerpoint/2010/main" val="2844301663"/>
+        <p14:creationId xmlns:p14="http://schemas.microsoft.com/office/powerpoint/2010/main" val="2172459460"/>
       </p:ext>
     </p:extLst>
   </p:cSld>
@@ -6524,19 +6605,52 @@
         </p:nvSpPr>
         <p:spPr>
           <a:xfrm>
-            <a:off x="3491318" y="1899753"/>
-            <a:ext cx="2299882" cy="968138"/>
+            <a:off x="311700" y="246254"/>
+            <a:ext cx="8520600" cy="572700"/>
           </a:xfrm>
         </p:spPr>
         <p:txBody>
           <a:bodyPr/>
           <a:lstStyle/>
           <a:p>
-            <a:r>
-              <a:rPr lang="pt-BR" sz="3200" dirty="0" smtClean="0"/>
-              <a:t>Subversion  </a:t>
-            </a:r>
-            <a:endParaRPr lang="pt-BR" sz="3200" dirty="0"/>
+            <a:pPr algn="ctr"/>
+            <a:r>
+              <a:rPr lang="pt-BR" dirty="0" smtClean="0"/>
+              <a:t>Reduzir Escopo</a:t>
+            </a:r>
+            <a:endParaRPr lang="pt-BR" dirty="0"/>
+          </a:p>
+        </p:txBody>
+      </p:sp>
+      <p:sp>
+        <p:nvSpPr>
+          <p:cNvPr id="3" name="Text Placeholder 2"/>
+          <p:cNvSpPr>
+            <a:spLocks noGrp="1"/>
+          </p:cNvSpPr>
+          <p:nvPr>
+            <p:ph type="body" idx="1"/>
+          </p:nvPr>
+        </p:nvSpPr>
+        <p:spPr/>
+        <p:txBody>
+          <a:bodyPr/>
+          <a:lstStyle/>
+          <a:p>
+            <a:r>
+              <a:rPr lang="pt-BR" sz="2000" dirty="0" smtClean="0"/>
+              <a:t>Utilize blocos aninhados para declarar variáveis locais de modo que tenham o menor escopo possível</a:t>
+            </a:r>
+          </a:p>
+          <a:p>
+            <a:endParaRPr lang="pt-BR" sz="2000" dirty="0"/>
+          </a:p>
+          <a:p>
+            <a:r>
+              <a:rPr lang="pt-BR" sz="2000" dirty="0" smtClean="0"/>
+              <a:t>Blocos aninhados também são úteis para delimitar a região de um comentário</a:t>
+            </a:r>
+            <a:endParaRPr lang="pt-BR" sz="2000" dirty="0"/>
           </a:p>
         </p:txBody>
       </p:sp>
@@ -6572,10 +6686,40 @@
           </a:p>
         </p:txBody>
       </p:sp>
+      <p:pic>
+        <p:nvPicPr>
+          <p:cNvPr id="5" name="Picture 4"/>
+          <p:cNvPicPr>
+            <a:picLocks noChangeAspect="1"/>
+          </p:cNvPicPr>
+          <p:nvPr/>
+        </p:nvPicPr>
+        <p:blipFill>
+          <a:blip r:embed="rId2">
+            <a:extLst>
+              <a:ext uri="{28A0092B-C50C-407E-A947-70E740481C1C}">
+                <a14:useLocalDpi xmlns:a14="http://schemas.microsoft.com/office/drawing/2010/main" val="0"/>
+              </a:ext>
+            </a:extLst>
+          </a:blip>
+          <a:stretch>
+            <a:fillRect/>
+          </a:stretch>
+        </p:blipFill>
+        <p:spPr>
+          <a:xfrm>
+            <a:off x="2245441" y="2659698"/>
+            <a:ext cx="707210" cy="568412"/>
+          </a:xfrm>
+          <a:prstGeom prst="rect">
+            <a:avLst/>
+          </a:prstGeom>
+        </p:spPr>
+      </p:pic>
     </p:spTree>
     <p:extLst>
       <p:ext uri="{BB962C8B-B14F-4D97-AF65-F5344CB8AC3E}">
-        <p14:creationId xmlns:p14="http://schemas.microsoft.com/office/powerpoint/2010/main" val="1107927960"/>
+        <p14:creationId xmlns:p14="http://schemas.microsoft.com/office/powerpoint/2010/main" val="3355828530"/>
       </p:ext>
     </p:extLst>
   </p:cSld>
@@ -6614,7 +6758,7 @@
         </p:nvSpPr>
         <p:spPr>
           <a:xfrm>
-            <a:off x="311700" y="246254"/>
+            <a:off x="311700" y="195644"/>
             <a:ext cx="8520600" cy="572700"/>
           </a:xfrm>
         </p:spPr>
@@ -6625,54 +6769,9 @@
             <a:pPr algn="ctr"/>
             <a:r>
               <a:rPr lang="pt-BR" dirty="0" smtClean="0"/>
-              <a:t>Subversion</a:t>
+              <a:t>Exemplo: Carro 3</a:t>
             </a:r>
             <a:endParaRPr lang="pt-BR" dirty="0"/>
-          </a:p>
-        </p:txBody>
-      </p:sp>
-      <p:sp>
-        <p:nvSpPr>
-          <p:cNvPr id="3" name="Text Placeholder 2"/>
-          <p:cNvSpPr>
-            <a:spLocks noGrp="1"/>
-          </p:cNvSpPr>
-          <p:nvPr>
-            <p:ph type="body" idx="1"/>
-          </p:nvPr>
-        </p:nvSpPr>
-        <p:spPr>
-          <a:xfrm>
-            <a:off x="311700" y="1032885"/>
-            <a:ext cx="8520600" cy="3416400"/>
-          </a:xfrm>
-        </p:spPr>
-        <p:txBody>
-          <a:bodyPr/>
-          <a:lstStyle/>
-          <a:p>
-            <a:r>
-              <a:rPr lang="pt-BR" sz="2000" dirty="0" smtClean="0"/>
-              <a:t>Subversion é um sistema de controle de versão de código aberto</a:t>
-            </a:r>
-          </a:p>
-          <a:p>
-            <a:endParaRPr lang="pt-BR" sz="2000" dirty="0"/>
-          </a:p>
-          <a:p>
-            <a:r>
-              <a:rPr lang="pt-BR" sz="2000" dirty="0" smtClean="0"/>
-              <a:t>Este SCV gerencia arquivos e diretórios, bem como as modificações feitas neles ao longo do tempo</a:t>
-            </a:r>
-          </a:p>
-          <a:p>
-            <a:endParaRPr lang="pt-BR" sz="2000" dirty="0"/>
-          </a:p>
-          <a:p>
-            <a:r>
-              <a:rPr lang="pt-BR" sz="2000" dirty="0" smtClean="0"/>
-              <a:t>Isto permite a recuperação de versões anteriores de arquivos de projetos e a análise do histórico das alterações nesses arquivos</a:t>
-            </a:r>
           </a:p>
         </p:txBody>
       </p:sp>
@@ -6708,10 +6807,40 @@
           </a:p>
         </p:txBody>
       </p:sp>
+      <p:pic>
+        <p:nvPicPr>
+          <p:cNvPr id="5" name="Picture 4"/>
+          <p:cNvPicPr>
+            <a:picLocks noChangeAspect="1"/>
+          </p:cNvPicPr>
+          <p:nvPr/>
+        </p:nvPicPr>
+        <p:blipFill>
+          <a:blip r:embed="rId2">
+            <a:extLst>
+              <a:ext uri="{28A0092B-C50C-407E-A947-70E740481C1C}">
+                <a14:useLocalDpi xmlns:a14="http://schemas.microsoft.com/office/drawing/2010/main" val="0"/>
+              </a:ext>
+            </a:extLst>
+          </a:blip>
+          <a:stretch>
+            <a:fillRect/>
+          </a:stretch>
+        </p:blipFill>
+        <p:spPr>
+          <a:xfrm>
+            <a:off x="1521527" y="947903"/>
+            <a:ext cx="5780809" cy="4046567"/>
+          </a:xfrm>
+          <a:prstGeom prst="rect">
+            <a:avLst/>
+          </a:prstGeom>
+        </p:spPr>
+      </p:pic>
     </p:spTree>
     <p:extLst>
       <p:ext uri="{BB962C8B-B14F-4D97-AF65-F5344CB8AC3E}">
-        <p14:creationId xmlns:p14="http://schemas.microsoft.com/office/powerpoint/2010/main" val="3951456305"/>
+        <p14:creationId xmlns:p14="http://schemas.microsoft.com/office/powerpoint/2010/main" val="3804635406"/>
       </p:ext>
     </p:extLst>
   </p:cSld>
@@ -6761,7 +6890,7 @@
             <a:pPr algn="ctr"/>
             <a:r>
               <a:rPr lang="pt-BR" dirty="0" smtClean="0"/>
-              <a:t>Características do Subversion</a:t>
+              <a:t>Declarações</a:t>
             </a:r>
             <a:endParaRPr lang="pt-BR" dirty="0"/>
           </a:p>
@@ -6784,45 +6913,40 @@
           <a:p>
             <a:r>
               <a:rPr lang="pt-BR" sz="2000" dirty="0" smtClean="0"/>
-              <a:t>Versionamento de diretórios</a:t>
-            </a:r>
-          </a:p>
-          <a:p>
-            <a:endParaRPr lang="pt-BR" sz="2000" dirty="0" smtClean="0"/>
+              <a:t>Evite nomear variáveis locais com o mesmo nome de variáveis globais</a:t>
+            </a:r>
+          </a:p>
+          <a:p>
+            <a:pPr lvl="1"/>
+            <a:r>
+              <a:rPr lang="pt-BR" sz="1800" dirty="0" smtClean="0"/>
+              <a:t>Ou com nomes de métodos da classe</a:t>
+            </a:r>
+          </a:p>
+          <a:p>
+            <a:pPr marL="596900" lvl="1" indent="0">
+              <a:buNone/>
+            </a:pPr>
+            <a:endParaRPr lang="pt-BR" dirty="0"/>
           </a:p>
           <a:p>
             <a:r>
               <a:rPr lang="pt-BR" sz="2000" dirty="0" smtClean="0"/>
-              <a:t>Histórico de versões efetivo</a:t>
-            </a:r>
-          </a:p>
-          <a:p>
-            <a:endParaRPr lang="pt-BR" sz="2000" dirty="0" smtClean="0"/>
-          </a:p>
-          <a:p>
-            <a:r>
-              <a:rPr lang="pt-BR" sz="2000" dirty="0" smtClean="0"/>
-              <a:t>Commits atômicos</a:t>
-            </a:r>
-          </a:p>
-          <a:p>
-            <a:endParaRPr lang="pt-BR" sz="2000" dirty="0" smtClean="0"/>
-          </a:p>
-          <a:p>
-            <a:r>
-              <a:rPr lang="pt-BR" sz="2000" dirty="0" smtClean="0"/>
-              <a:t>Versionamento de metadados</a:t>
-            </a:r>
-          </a:p>
-          <a:p>
-            <a:endParaRPr lang="pt-BR" sz="2000" dirty="0" smtClean="0"/>
-          </a:p>
-          <a:p>
-            <a:r>
-              <a:rPr lang="pt-BR" sz="2000" dirty="0" smtClean="0"/>
-              <a:t>“Adaptabilidade”</a:t>
+              <a:t>Sempre que possível, declare e inicialize as variáveis em um mesmo comando</a:t>
             </a:r>
             <a:endParaRPr lang="pt-BR" sz="2000" dirty="0"/>
+          </a:p>
+          <a:p>
+            <a:pPr lvl="1"/>
+            <a:endParaRPr lang="pt-BR" dirty="0" smtClean="0"/>
+          </a:p>
+          <a:p>
+            <a:pPr lvl="1"/>
+            <a:endParaRPr lang="pt-BR" dirty="0"/>
+          </a:p>
+          <a:p>
+            <a:pPr lvl="1"/>
+            <a:endParaRPr lang="pt-BR" dirty="0" smtClean="0"/>
           </a:p>
         </p:txBody>
       </p:sp>
@@ -6858,10 +6982,70 @@
           </a:p>
         </p:txBody>
       </p:sp>
+      <p:pic>
+        <p:nvPicPr>
+          <p:cNvPr id="5" name="Picture 4"/>
+          <p:cNvPicPr>
+            <a:picLocks noChangeAspect="1"/>
+          </p:cNvPicPr>
+          <p:nvPr/>
+        </p:nvPicPr>
+        <p:blipFill>
+          <a:blip r:embed="rId2">
+            <a:extLst>
+              <a:ext uri="{28A0092B-C50C-407E-A947-70E740481C1C}">
+                <a14:useLocalDpi xmlns:a14="http://schemas.microsoft.com/office/drawing/2010/main" val="0"/>
+              </a:ext>
+            </a:extLst>
+          </a:blip>
+          <a:stretch>
+            <a:fillRect/>
+          </a:stretch>
+        </p:blipFill>
+        <p:spPr>
+          <a:xfrm>
+            <a:off x="1844353" y="1585970"/>
+            <a:ext cx="600974" cy="492226"/>
+          </a:xfrm>
+          <a:prstGeom prst="rect">
+            <a:avLst/>
+          </a:prstGeom>
+        </p:spPr>
+      </p:pic>
+      <p:pic>
+        <p:nvPicPr>
+          <p:cNvPr id="6" name="Picture 5"/>
+          <p:cNvPicPr>
+            <a:picLocks noChangeAspect="1"/>
+          </p:cNvPicPr>
+          <p:nvPr/>
+        </p:nvPicPr>
+        <p:blipFill>
+          <a:blip r:embed="rId3">
+            <a:extLst>
+              <a:ext uri="{28A0092B-C50C-407E-A947-70E740481C1C}">
+                <a14:useLocalDpi xmlns:a14="http://schemas.microsoft.com/office/drawing/2010/main" val="0"/>
+              </a:ext>
+            </a:extLst>
+          </a:blip>
+          <a:stretch>
+            <a:fillRect/>
+          </a:stretch>
+        </p:blipFill>
+        <p:spPr>
+          <a:xfrm>
+            <a:off x="2051606" y="3282460"/>
+            <a:ext cx="621187" cy="520614"/>
+          </a:xfrm>
+          <a:prstGeom prst="rect">
+            <a:avLst/>
+          </a:prstGeom>
+        </p:spPr>
+      </p:pic>
     </p:spTree>
     <p:extLst>
       <p:ext uri="{BB962C8B-B14F-4D97-AF65-F5344CB8AC3E}">
-        <p14:creationId xmlns:p14="http://schemas.microsoft.com/office/powerpoint/2010/main" val="2109540904"/>
+        <p14:creationId xmlns:p14="http://schemas.microsoft.com/office/powerpoint/2010/main" val="3496352786"/>
       </p:ext>
     </p:extLst>
   </p:cSld>
@@ -6900,7 +7084,7 @@
         </p:nvSpPr>
         <p:spPr>
           <a:xfrm>
-            <a:off x="311700" y="246254"/>
+            <a:off x="311700" y="299552"/>
             <a:ext cx="8520600" cy="572700"/>
           </a:xfrm>
         </p:spPr>
@@ -6911,7 +7095,7 @@
             <a:pPr algn="ctr"/>
             <a:r>
               <a:rPr lang="pt-BR" dirty="0" smtClean="0"/>
-              <a:t>Versionamento de diretórios</a:t>
+              <a:t>Expressões</a:t>
             </a:r>
             <a:endParaRPr lang="pt-BR" dirty="0"/>
           </a:p>
@@ -6927,30 +7111,34 @@
             <p:ph type="body" idx="1"/>
           </p:nvPr>
         </p:nvSpPr>
-        <p:spPr>
-          <a:xfrm>
-            <a:off x="311700" y="1032885"/>
-            <a:ext cx="8520600" cy="3416400"/>
-          </a:xfrm>
-        </p:spPr>
+        <p:spPr/>
         <p:txBody>
           <a:bodyPr/>
           <a:lstStyle/>
           <a:p>
             <a:r>
               <a:rPr lang="pt-BR" sz="2000" dirty="0" smtClean="0"/>
-              <a:t>O Subversion (SVN) implementa um sistema de arquivos “virtual”</a:t>
-            </a:r>
-          </a:p>
-          <a:p>
-            <a:endParaRPr lang="pt-BR" sz="2000" dirty="0"/>
-          </a:p>
-          <a:p>
-            <a:r>
-              <a:rPr lang="pt-BR" sz="2000" dirty="0" smtClean="0"/>
-              <a:t>Esse diretório fica sob controle de versão que rastreia modificações a toda a árvore de diretório ao longo do tempo</a:t>
-            </a:r>
-            <a:endParaRPr lang="pt-BR" sz="2000" dirty="0"/>
+              <a:t>Evite o uso de operador ternário “?” quando uma das expressões contiver mais de um operador</a:t>
+            </a:r>
+          </a:p>
+          <a:p>
+            <a:pPr lvl="1"/>
+            <a:r>
+              <a:rPr lang="pt-BR" sz="1800" dirty="0" smtClean="0"/>
+              <a:t>Neste caso, use o comando </a:t>
+            </a:r>
+            <a:r>
+              <a:rPr lang="pt-BR" sz="1800" i="1" dirty="0" smtClean="0"/>
+              <a:t>if</a:t>
+            </a:r>
+          </a:p>
+          <a:p>
+            <a:pPr lvl="1"/>
+            <a:endParaRPr lang="pt-BR" sz="1800" i="1" dirty="0"/>
+          </a:p>
+          <a:p>
+            <a:pPr lvl="1"/>
+            <a:endParaRPr lang="pt-BR" sz="1800" i="1" dirty="0" smtClean="0"/>
           </a:p>
         </p:txBody>
       </p:sp>
@@ -7008,8 +7196,38 @@
         </p:blipFill>
         <p:spPr>
           <a:xfrm>
-            <a:off x="1992446" y="2739257"/>
-            <a:ext cx="3293063" cy="2317560"/>
+            <a:off x="311700" y="2754140"/>
+            <a:ext cx="5971337" cy="1693365"/>
+          </a:xfrm>
+          <a:prstGeom prst="rect">
+            <a:avLst/>
+          </a:prstGeom>
+        </p:spPr>
+      </p:pic>
+      <p:pic>
+        <p:nvPicPr>
+          <p:cNvPr id="6" name="Picture 5"/>
+          <p:cNvPicPr>
+            <a:picLocks noChangeAspect="1"/>
+          </p:cNvPicPr>
+          <p:nvPr/>
+        </p:nvPicPr>
+        <p:blipFill>
+          <a:blip r:embed="rId3">
+            <a:extLst>
+              <a:ext uri="{28A0092B-C50C-407E-A947-70E740481C1C}">
+                <a14:useLocalDpi xmlns:a14="http://schemas.microsoft.com/office/drawing/2010/main" val="0"/>
+              </a:ext>
+            </a:extLst>
+          </a:blip>
+          <a:stretch>
+            <a:fillRect/>
+          </a:stretch>
+        </p:blipFill>
+        <p:spPr>
+          <a:xfrm>
+            <a:off x="4867759" y="1777248"/>
+            <a:ext cx="674059" cy="553236"/>
           </a:xfrm>
           <a:prstGeom prst="rect">
             <a:avLst/>
@@ -7019,7 +7237,7 @@
     </p:spTree>
     <p:extLst>
       <p:ext uri="{BB962C8B-B14F-4D97-AF65-F5344CB8AC3E}">
-        <p14:creationId xmlns:p14="http://schemas.microsoft.com/office/powerpoint/2010/main" val="3870478510"/>
+        <p14:creationId xmlns:p14="http://schemas.microsoft.com/office/powerpoint/2010/main" val="3254832211"/>
       </p:ext>
     </p:extLst>
   </p:cSld>
@@ -7058,7 +7276,7 @@
         </p:nvSpPr>
         <p:spPr>
           <a:xfrm>
-            <a:off x="311700" y="257988"/>
+            <a:off x="311700" y="246254"/>
             <a:ext cx="8520600" cy="572700"/>
           </a:xfrm>
         </p:spPr>
@@ -7068,8 +7286,12 @@
           <a:p>
             <a:pPr algn="ctr"/>
             <a:r>
+              <a:rPr lang="pt-BR" i="1" dirty="0" smtClean="0"/>
+              <a:t>Switch</a:t>
+            </a:r>
+            <a:r>
               <a:rPr lang="pt-BR" dirty="0" smtClean="0"/>
-              <a:t>Histórico de versões efetivo</a:t>
+              <a:t> Case</a:t>
             </a:r>
             <a:endParaRPr lang="pt-BR" dirty="0"/>
           </a:p>
@@ -7085,30 +7307,84 @@
             <p:ph type="body" idx="1"/>
           </p:nvPr>
         </p:nvSpPr>
-        <p:spPr>
-          <a:xfrm>
-            <a:off x="311700" y="1076852"/>
-            <a:ext cx="8520600" cy="3416400"/>
-          </a:xfrm>
-        </p:spPr>
+        <p:spPr/>
         <p:txBody>
           <a:bodyPr/>
           <a:lstStyle/>
           <a:p>
             <a:r>
               <a:rPr lang="pt-BR" sz="2000" dirty="0" smtClean="0"/>
-              <a:t>O SVN permite a adição, exclusão, cópia e renomeação de arquivos ou diretórios</a:t>
-            </a:r>
-          </a:p>
-          <a:p>
-            <a:endParaRPr lang="pt-BR" sz="2000" dirty="0"/>
-          </a:p>
-          <a:p>
+              <a:t>Mantenha curto o código de cada </a:t>
+            </a:r>
+            <a:r>
+              <a:rPr lang="pt-BR" sz="2000" i="1" dirty="0" smtClean="0"/>
+              <a:t>case </a:t>
+            </a:r>
             <a:r>
               <a:rPr lang="pt-BR" sz="2000" dirty="0" smtClean="0"/>
-              <a:t>Para cada novo arquivo adicionado no repositório, um novo histórico é criado com o objetivo de controlar todas as alterações feitas</a:t>
-            </a:r>
-            <a:endParaRPr lang="pt-BR" sz="2000" dirty="0"/>
+              <a:t>de</a:t>
+            </a:r>
+            <a:r>
+              <a:rPr lang="pt-BR" sz="2000" i="1" dirty="0" smtClean="0"/>
+              <a:t> </a:t>
+            </a:r>
+            <a:r>
+              <a:rPr lang="pt-BR" sz="2000" dirty="0" smtClean="0"/>
+              <a:t>um</a:t>
+            </a:r>
+            <a:r>
+              <a:rPr lang="pt-BR" sz="2000" i="1" dirty="0" smtClean="0"/>
+              <a:t> switch</a:t>
+            </a:r>
+          </a:p>
+          <a:p>
+            <a:pPr lvl="1"/>
+            <a:r>
+              <a:rPr lang="pt-BR" sz="1800" dirty="0" smtClean="0"/>
+              <a:t>Em torno de 5 linhas</a:t>
+            </a:r>
+          </a:p>
+          <a:p>
+            <a:pPr lvl="1"/>
+            <a:r>
+              <a:rPr lang="pt-BR" sz="1800" dirty="0" smtClean="0"/>
+              <a:t>Código longo deve ser extraído para um método</a:t>
+            </a:r>
+          </a:p>
+          <a:p>
+            <a:pPr lvl="1"/>
+            <a:endParaRPr lang="pt-BR" dirty="0"/>
+          </a:p>
+          <a:p>
+            <a:r>
+              <a:rPr lang="pt-BR" sz="2000" dirty="0" smtClean="0"/>
+              <a:t>Sempre termine o </a:t>
+            </a:r>
+            <a:r>
+              <a:rPr lang="pt-BR" sz="2000" i="1" dirty="0" smtClean="0"/>
+              <a:t>case </a:t>
+            </a:r>
+            <a:r>
+              <a:rPr lang="pt-BR" sz="2000" dirty="0" smtClean="0"/>
+              <a:t>com um comando </a:t>
+            </a:r>
+            <a:r>
+              <a:rPr lang="pt-BR" sz="2000" i="1" dirty="0" smtClean="0"/>
+              <a:t>break</a:t>
+            </a:r>
+            <a:endParaRPr lang="pt-BR" sz="2000" i="1" dirty="0"/>
+          </a:p>
+          <a:p>
+            <a:pPr lvl="1"/>
+            <a:endParaRPr lang="pt-BR" dirty="0"/>
+          </a:p>
+          <a:p>
+            <a:pPr lvl="1"/>
+            <a:endParaRPr lang="pt-BR" dirty="0"/>
+          </a:p>
+          <a:p>
+            <a:pPr lvl="1"/>
+            <a:endParaRPr lang="pt-BR" dirty="0"/>
           </a:p>
         </p:txBody>
       </p:sp>
@@ -7144,10 +7420,70 @@
           </a:p>
         </p:txBody>
       </p:sp>
+      <p:pic>
+        <p:nvPicPr>
+          <p:cNvPr id="5" name="Picture 4"/>
+          <p:cNvPicPr>
+            <a:picLocks noChangeAspect="1"/>
+          </p:cNvPicPr>
+          <p:nvPr/>
+        </p:nvPicPr>
+        <p:blipFill>
+          <a:blip r:embed="rId2">
+            <a:extLst>
+              <a:ext uri="{28A0092B-C50C-407E-A947-70E740481C1C}">
+                <a14:useLocalDpi xmlns:a14="http://schemas.microsoft.com/office/drawing/2010/main" val="0"/>
+              </a:ext>
+            </a:extLst>
+          </a:blip>
+          <a:stretch>
+            <a:fillRect/>
+          </a:stretch>
+        </p:blipFill>
+        <p:spPr>
+          <a:xfrm>
+            <a:off x="6488741" y="1725834"/>
+            <a:ext cx="667130" cy="553843"/>
+          </a:xfrm>
+          <a:prstGeom prst="rect">
+            <a:avLst/>
+          </a:prstGeom>
+        </p:spPr>
+      </p:pic>
+      <p:pic>
+        <p:nvPicPr>
+          <p:cNvPr id="6" name="Picture 5"/>
+          <p:cNvPicPr>
+            <a:picLocks noChangeAspect="1"/>
+          </p:cNvPicPr>
+          <p:nvPr/>
+        </p:nvPicPr>
+        <p:blipFill>
+          <a:blip r:embed="rId3">
+            <a:extLst>
+              <a:ext uri="{28A0092B-C50C-407E-A947-70E740481C1C}">
+                <a14:useLocalDpi xmlns:a14="http://schemas.microsoft.com/office/drawing/2010/main" val="0"/>
+              </a:ext>
+            </a:extLst>
+          </a:blip>
+          <a:stretch>
+            <a:fillRect/>
+          </a:stretch>
+        </p:blipFill>
+        <p:spPr>
+          <a:xfrm>
+            <a:off x="6488741" y="2870736"/>
+            <a:ext cx="674059" cy="553237"/>
+          </a:xfrm>
+          <a:prstGeom prst="rect">
+            <a:avLst/>
+          </a:prstGeom>
+        </p:spPr>
+      </p:pic>
     </p:spTree>
     <p:extLst>
       <p:ext uri="{BB962C8B-B14F-4D97-AF65-F5344CB8AC3E}">
-        <p14:creationId xmlns:p14="http://schemas.microsoft.com/office/powerpoint/2010/main" val="1089730513"/>
+        <p14:creationId xmlns:p14="http://schemas.microsoft.com/office/powerpoint/2010/main" val="101777935"/>
       </p:ext>
     </p:extLst>
   </p:cSld>
@@ -7196,10 +7532,18 @@
           <a:p>
             <a:pPr algn="ctr"/>
             <a:r>
+              <a:rPr lang="pt-BR" i="1" dirty="0" smtClean="0"/>
+              <a:t>Default</a:t>
+            </a:r>
+            <a:r>
               <a:rPr lang="pt-BR" dirty="0" smtClean="0"/>
-              <a:t>Commits atômicos</a:t>
-            </a:r>
-            <a:endParaRPr lang="pt-BR" dirty="0"/>
+              <a:t> de um </a:t>
+            </a:r>
+            <a:r>
+              <a:rPr lang="pt-BR" i="1" dirty="0" smtClean="0"/>
+              <a:t>Switch</a:t>
+            </a:r>
+            <a:endParaRPr lang="pt-BR" i="1" dirty="0"/>
           </a:p>
         </p:txBody>
       </p:sp>
@@ -7220,18 +7564,42 @@
           <a:p>
             <a:r>
               <a:rPr lang="pt-BR" sz="2000" dirty="0" smtClean="0"/>
-              <a:t>Um conjunto de modificações são inteiramente registradas no repositório ou não são registradas de forma nenhuma</a:t>
-            </a:r>
-          </a:p>
-          <a:p>
-            <a:endParaRPr lang="pt-BR" sz="2000" dirty="0"/>
-          </a:p>
-          <a:p>
+              <a:t>Sempre inclua uma opção </a:t>
+            </a:r>
+            <a:r>
+              <a:rPr lang="pt-BR" sz="2000" i="1" dirty="0" smtClean="0"/>
+              <a:t>default </a:t>
+            </a:r>
             <a:r>
               <a:rPr lang="pt-BR" sz="2000" dirty="0" smtClean="0"/>
-              <a:t>Isto evita problemas que possam ocorrer quando apenas uma parte de um conjunto de alterações seja enviada com sucesso ao repositório</a:t>
-            </a:r>
-            <a:endParaRPr lang="pt-BR" sz="2000" dirty="0"/>
+              <a:t>nas estruturas </a:t>
+            </a:r>
+            <a:r>
+              <a:rPr lang="pt-BR" sz="2000" i="1" dirty="0" smtClean="0"/>
+              <a:t>switch</a:t>
+            </a:r>
+          </a:p>
+          <a:p>
+            <a:endParaRPr lang="pt-BR" sz="2000" i="1" dirty="0"/>
+          </a:p>
+          <a:p>
+            <a:r>
+              <a:rPr lang="pt-BR" sz="2000" dirty="0" smtClean="0"/>
+              <a:t>O </a:t>
+            </a:r>
+            <a:r>
+              <a:rPr lang="pt-BR" sz="2000" i="1" dirty="0" smtClean="0"/>
+              <a:t>default </a:t>
+            </a:r>
+            <a:r>
+              <a:rPr lang="pt-BR" sz="2000" dirty="0" smtClean="0"/>
+              <a:t>deve capturar somente as condições não previstas pelos </a:t>
+            </a:r>
+            <a:r>
+              <a:rPr lang="pt-BR" sz="2000" i="1" dirty="0" smtClean="0"/>
+              <a:t>case</a:t>
+            </a:r>
+            <a:endParaRPr lang="pt-BR" sz="2000" i="1" dirty="0"/>
           </a:p>
         </p:txBody>
       </p:sp>
@@ -7267,10 +7635,70 @@
           </a:p>
         </p:txBody>
       </p:sp>
+      <p:pic>
+        <p:nvPicPr>
+          <p:cNvPr id="5" name="Picture 4"/>
+          <p:cNvPicPr>
+            <a:picLocks noChangeAspect="1"/>
+          </p:cNvPicPr>
+          <p:nvPr/>
+        </p:nvPicPr>
+        <p:blipFill>
+          <a:blip r:embed="rId2">
+            <a:extLst>
+              <a:ext uri="{28A0092B-C50C-407E-A947-70E740481C1C}">
+                <a14:useLocalDpi xmlns:a14="http://schemas.microsoft.com/office/drawing/2010/main" val="0"/>
+              </a:ext>
+            </a:extLst>
+          </a:blip>
+          <a:stretch>
+            <a:fillRect/>
+          </a:stretch>
+        </p:blipFill>
+        <p:spPr>
+          <a:xfrm>
+            <a:off x="7281568" y="1215015"/>
+            <a:ext cx="691723" cy="562428"/>
+          </a:xfrm>
+          <a:prstGeom prst="rect">
+            <a:avLst/>
+          </a:prstGeom>
+        </p:spPr>
+      </p:pic>
+      <p:pic>
+        <p:nvPicPr>
+          <p:cNvPr id="6" name="Picture 5"/>
+          <p:cNvPicPr>
+            <a:picLocks noChangeAspect="1"/>
+          </p:cNvPicPr>
+          <p:nvPr/>
+        </p:nvPicPr>
+        <p:blipFill>
+          <a:blip r:embed="rId3">
+            <a:extLst>
+              <a:ext uri="{28A0092B-C50C-407E-A947-70E740481C1C}">
+                <a14:useLocalDpi xmlns:a14="http://schemas.microsoft.com/office/drawing/2010/main" val="0"/>
+              </a:ext>
+            </a:extLst>
+          </a:blip>
+          <a:stretch>
+            <a:fillRect/>
+          </a:stretch>
+        </p:blipFill>
+        <p:spPr>
+          <a:xfrm>
+            <a:off x="1608824" y="2298431"/>
+            <a:ext cx="677176" cy="573988"/>
+          </a:xfrm>
+          <a:prstGeom prst="rect">
+            <a:avLst/>
+          </a:prstGeom>
+        </p:spPr>
+      </p:pic>
     </p:spTree>
     <p:extLst>
       <p:ext uri="{BB962C8B-B14F-4D97-AF65-F5344CB8AC3E}">
-        <p14:creationId xmlns:p14="http://schemas.microsoft.com/office/powerpoint/2010/main" val="934928936"/>
+        <p14:creationId xmlns:p14="http://schemas.microsoft.com/office/powerpoint/2010/main" val="1796789987"/>
       </p:ext>
     </p:extLst>
   </p:cSld>
@@ -7309,7 +7737,7 @@
         </p:nvSpPr>
         <p:spPr>
           <a:xfrm>
-            <a:off x="311700" y="334189"/>
+            <a:off x="311700" y="306480"/>
             <a:ext cx="8520600" cy="572700"/>
           </a:xfrm>
         </p:spPr>
@@ -7320,7 +7748,7 @@
             <a:pPr algn="ctr"/>
             <a:r>
               <a:rPr lang="pt-BR" dirty="0" smtClean="0"/>
-              <a:t>Versionamento de metadados</a:t>
+              <a:t>Repetições</a:t>
             </a:r>
             <a:endParaRPr lang="pt-BR" dirty="0"/>
           </a:p>
@@ -7343,14 +7771,43 @@
           <a:p>
             <a:r>
               <a:rPr lang="pt-BR" sz="2000" dirty="0" smtClean="0"/>
-              <a:t>Metadados são dados sobre outros dados. Todos os dados descritivos de um documento, físico ou digital, sobre autor, data de criação, local de criação, conteúdo e forma são versionados</a:t>
+              <a:t>Não crie variáveis temporárias apenas para término de uma repetição</a:t>
             </a:r>
           </a:p>
           <a:p>
             <a:endParaRPr lang="pt-BR" sz="2000" dirty="0"/>
           </a:p>
           <a:p>
-            <a:endParaRPr lang="pt-BR" sz="2000" dirty="0"/>
+            <a:r>
+              <a:rPr lang="pt-BR" sz="2000" dirty="0" smtClean="0"/>
+              <a:t>Use o comando </a:t>
+            </a:r>
+            <a:r>
+              <a:rPr lang="pt-BR" sz="2000" i="1" dirty="0" smtClean="0"/>
+              <a:t>break </a:t>
+            </a:r>
+            <a:r>
+              <a:rPr lang="pt-BR" sz="2000" dirty="0" smtClean="0"/>
+              <a:t>para sair de um laço de repetição antes da condição de saída ser atingida</a:t>
+            </a:r>
+          </a:p>
+          <a:p>
+            <a:endParaRPr lang="pt-BR" sz="2000" i="1" dirty="0"/>
+          </a:p>
+          <a:p>
+            <a:r>
+              <a:rPr lang="pt-BR" sz="2000" dirty="0" smtClean="0"/>
+              <a:t>Use o comando </a:t>
+            </a:r>
+            <a:r>
+              <a:rPr lang="pt-BR" sz="2000" i="1" dirty="0" smtClean="0"/>
+              <a:t>continue </a:t>
+            </a:r>
+            <a:r>
+              <a:rPr lang="pt-BR" sz="2000" dirty="0" smtClean="0"/>
+              <a:t>para testar imediatamente a condição de saída</a:t>
+            </a:r>
+            <a:endParaRPr lang="pt-BR" sz="2000" i="1" dirty="0"/>
           </a:p>
         </p:txBody>
       </p:sp>
@@ -7386,10 +7843,40 @@
           </a:p>
         </p:txBody>
       </p:sp>
+      <p:pic>
+        <p:nvPicPr>
+          <p:cNvPr id="5" name="Picture 4"/>
+          <p:cNvPicPr>
+            <a:picLocks noChangeAspect="1"/>
+          </p:cNvPicPr>
+          <p:nvPr/>
+        </p:nvPicPr>
+        <p:blipFill>
+          <a:blip r:embed="rId2">
+            <a:extLst>
+              <a:ext uri="{28A0092B-C50C-407E-A947-70E740481C1C}">
+                <a14:useLocalDpi xmlns:a14="http://schemas.microsoft.com/office/drawing/2010/main" val="0"/>
+              </a:ext>
+            </a:extLst>
+          </a:blip>
+          <a:stretch>
+            <a:fillRect/>
+          </a:stretch>
+        </p:blipFill>
+        <p:spPr>
+          <a:xfrm>
+            <a:off x="4632232" y="2296074"/>
+            <a:ext cx="704091" cy="564601"/>
+          </a:xfrm>
+          <a:prstGeom prst="rect">
+            <a:avLst/>
+          </a:prstGeom>
+        </p:spPr>
+      </p:pic>
     </p:spTree>
     <p:extLst>
       <p:ext uri="{BB962C8B-B14F-4D97-AF65-F5344CB8AC3E}">
-        <p14:creationId xmlns:p14="http://schemas.microsoft.com/office/powerpoint/2010/main" val="162183637"/>
+        <p14:creationId xmlns:p14="http://schemas.microsoft.com/office/powerpoint/2010/main" val="2616192572"/>
       </p:ext>
     </p:extLst>
   </p:cSld>
@@ -7439,7 +7926,7 @@
             <a:pPr algn="ctr"/>
             <a:r>
               <a:rPr lang="pt-BR" dirty="0" smtClean="0"/>
-              <a:t>Sistemas de Controle de Versão</a:t>
+              <a:t>Definição de Idiomas</a:t>
             </a:r>
             <a:endParaRPr lang="pt-BR" dirty="0"/>
           </a:p>
@@ -7472,7 +7959,7 @@
             </a:pPr>
             <a:r>
               <a:rPr lang="pt-BR" sz="2000" dirty="0" smtClean="0"/>
-              <a:t>Um sistema de controle de versão (SCV) tem a finalidade de gerenciar diferentes versões de um artefato</a:t>
+              <a:t>Idiomas são padrões de baixo nível específicos de uma linguagem de programação</a:t>
             </a:r>
           </a:p>
           <a:p>
@@ -7491,11 +7978,48 @@
             </a:pPr>
             <a:r>
               <a:rPr lang="pt-BR" sz="2000" dirty="0" smtClean="0"/>
-              <a:t>SCVs oferecem uma maneira muito mais inteligente de organizar projetos, uma vez que eles possibilitam acompanhar o histórico de desenvolvimento	</a:t>
-            </a:r>
-            <a:r>
-              <a:rPr lang="pt-BR" sz="1600" dirty="0" smtClean="0"/>
-              <a:t>	</a:t>
+              <a:t>Cada idioma descreve como resolver um problema de programação em uma determinada linguagem</a:t>
+            </a:r>
+          </a:p>
+          <a:p>
+            <a:pPr>
+              <a:lnSpc>
+                <a:spcPct val="100000"/>
+              </a:lnSpc>
+            </a:pPr>
+            <a:endParaRPr lang="pt-BR" sz="2000" dirty="0"/>
+          </a:p>
+          <a:p>
+            <a:pPr>
+              <a:lnSpc>
+                <a:spcPct val="100000"/>
+              </a:lnSpc>
+            </a:pPr>
+            <a:r>
+              <a:rPr lang="pt-BR" sz="2000" dirty="0" smtClean="0"/>
+              <a:t>Idiomas facilitam a comunicação entre programadores</a:t>
+            </a:r>
+          </a:p>
+          <a:p>
+            <a:pPr lvl="1">
+              <a:lnSpc>
+                <a:spcPct val="100000"/>
+              </a:lnSpc>
+            </a:pPr>
+            <a:r>
+              <a:rPr lang="pt-BR" sz="1800" dirty="0" smtClean="0"/>
+              <a:t>Aceleram o desenvolvimento</a:t>
+            </a:r>
+          </a:p>
+          <a:p>
+            <a:pPr lvl="1">
+              <a:lnSpc>
+                <a:spcPct val="100000"/>
+              </a:lnSpc>
+            </a:pPr>
+            <a:r>
+              <a:rPr lang="pt-BR" sz="1800" dirty="0" smtClean="0"/>
+              <a:t>Facilitam atividades de manutenção de software</a:t>
             </a:r>
           </a:p>
         </p:txBody>
@@ -7574,7 +8098,7 @@
         </p:nvSpPr>
         <p:spPr>
           <a:xfrm>
-            <a:off x="311700" y="246254"/>
+            <a:off x="311700" y="320334"/>
             <a:ext cx="8520600" cy="572700"/>
           </a:xfrm>
         </p:spPr>
@@ -7585,7 +8109,7 @@
             <a:pPr algn="ctr"/>
             <a:r>
               <a:rPr lang="pt-BR" dirty="0" smtClean="0"/>
-              <a:t>Adaptabilidade</a:t>
+              <a:t>Expressões</a:t>
             </a:r>
             <a:endParaRPr lang="pt-BR" dirty="0"/>
           </a:p>
@@ -7608,18 +8132,42 @@
           <a:p>
             <a:r>
               <a:rPr lang="pt-BR" sz="2000" dirty="0" smtClean="0"/>
-              <a:t>O SVN está implementado como um conjunto de bibliotecas C compartilhadas com APIs bem definidas</a:t>
-            </a:r>
-          </a:p>
-          <a:p>
+              <a:t>Evite expressões lógicas complexas como a condição de um </a:t>
+            </a:r>
+            <a:r>
+              <a:rPr lang="pt-BR" sz="2000" i="1" dirty="0" smtClean="0"/>
+              <a:t>if</a:t>
+            </a:r>
+          </a:p>
+          <a:p>
+            <a:pPr lvl="1"/>
+            <a:r>
+              <a:rPr lang="pt-BR" sz="1800" dirty="0" smtClean="0"/>
+              <a:t>Particione-as em vários comandos </a:t>
+            </a:r>
+            <a:r>
+              <a:rPr lang="pt-BR" sz="1800" i="1" dirty="0" smtClean="0"/>
+              <a:t>if</a:t>
+            </a:r>
+            <a:r>
+              <a:rPr lang="pt-BR" sz="1800" dirty="0" smtClean="0"/>
+              <a:t> aninhados</a:t>
+            </a:r>
+          </a:p>
+          <a:p>
+            <a:pPr lvl="1"/>
+            <a:endParaRPr lang="pt-BR" sz="1800" dirty="0" smtClean="0"/>
+          </a:p>
+          <a:p>
+            <a:r>
+              <a:rPr lang="pt-BR" sz="2000" dirty="0" smtClean="0"/>
+              <a:t>Todos os blocos { } vazios devem receber um comentário indicando que estão propositalmente vazios</a:t>
+            </a:r>
             <a:endParaRPr lang="pt-BR" sz="2000" dirty="0"/>
           </a:p>
           <a:p>
-            <a:r>
-              <a:rPr lang="pt-BR" sz="2000" dirty="0" smtClean="0"/>
-              <a:t>Isto torna o SVN extremamente manutenível e usável por outras aplicações e linguagens</a:t>
-            </a:r>
-            <a:endParaRPr lang="pt-BR" sz="2000" dirty="0"/>
+            <a:pPr lvl="1"/>
+            <a:endParaRPr lang="pt-BR" sz="1800" dirty="0"/>
           </a:p>
         </p:txBody>
       </p:sp>
@@ -7655,10 +8203,70 @@
           </a:p>
         </p:txBody>
       </p:sp>
+      <p:pic>
+        <p:nvPicPr>
+          <p:cNvPr id="5" name="Picture 4"/>
+          <p:cNvPicPr>
+            <a:picLocks noChangeAspect="1"/>
+          </p:cNvPicPr>
+          <p:nvPr/>
+        </p:nvPicPr>
+        <p:blipFill>
+          <a:blip r:embed="rId2">
+            <a:extLst>
+              <a:ext uri="{28A0092B-C50C-407E-A947-70E740481C1C}">
+                <a14:useLocalDpi xmlns:a14="http://schemas.microsoft.com/office/drawing/2010/main" val="0"/>
+              </a:ext>
+            </a:extLst>
+          </a:blip>
+          <a:stretch>
+            <a:fillRect/>
+          </a:stretch>
+        </p:blipFill>
+        <p:spPr>
+          <a:xfrm>
+            <a:off x="6322488" y="1679142"/>
+            <a:ext cx="722510" cy="593003"/>
+          </a:xfrm>
+          <a:prstGeom prst="rect">
+            <a:avLst/>
+          </a:prstGeom>
+        </p:spPr>
+      </p:pic>
+      <p:pic>
+        <p:nvPicPr>
+          <p:cNvPr id="6" name="Picture 5"/>
+          <p:cNvPicPr>
+            <a:picLocks noChangeAspect="1"/>
+          </p:cNvPicPr>
+          <p:nvPr/>
+        </p:nvPicPr>
+        <p:blipFill>
+          <a:blip r:embed="rId3">
+            <a:extLst>
+              <a:ext uri="{28A0092B-C50C-407E-A947-70E740481C1C}">
+                <a14:useLocalDpi xmlns:a14="http://schemas.microsoft.com/office/drawing/2010/main" val="0"/>
+              </a:ext>
+            </a:extLst>
+          </a:blip>
+          <a:stretch>
+            <a:fillRect/>
+          </a:stretch>
+        </p:blipFill>
+        <p:spPr>
+          <a:xfrm>
+            <a:off x="4801604" y="2965885"/>
+            <a:ext cx="691724" cy="530106"/>
+          </a:xfrm>
+          <a:prstGeom prst="rect">
+            <a:avLst/>
+          </a:prstGeom>
+        </p:spPr>
+      </p:pic>
     </p:spTree>
     <p:extLst>
       <p:ext uri="{BB962C8B-B14F-4D97-AF65-F5344CB8AC3E}">
-        <p14:creationId xmlns:p14="http://schemas.microsoft.com/office/powerpoint/2010/main" val="3860985492"/>
+        <p14:creationId xmlns:p14="http://schemas.microsoft.com/office/powerpoint/2010/main" val="2480402779"/>
       </p:ext>
     </p:extLst>
   </p:cSld>
@@ -7697,19 +8305,99 @@
         </p:nvSpPr>
         <p:spPr>
           <a:xfrm>
-            <a:off x="3913881" y="1969026"/>
-            <a:ext cx="1059900" cy="968138"/>
+            <a:off x="311700" y="299552"/>
+            <a:ext cx="8520600" cy="572700"/>
           </a:xfrm>
         </p:spPr>
         <p:txBody>
           <a:bodyPr/>
           <a:lstStyle/>
           <a:p>
-            <a:r>
-              <a:rPr lang="pt-BR" sz="3200" dirty="0" smtClean="0"/>
-              <a:t>GIT  </a:t>
-            </a:r>
-            <a:endParaRPr lang="pt-BR" sz="3200" dirty="0"/>
+            <a:pPr algn="ctr"/>
+            <a:r>
+              <a:rPr lang="pt-BR" dirty="0" smtClean="0"/>
+              <a:t>Bibliografia</a:t>
+            </a:r>
+            <a:endParaRPr lang="pt-BR" dirty="0"/>
+          </a:p>
+        </p:txBody>
+      </p:sp>
+      <p:sp>
+        <p:nvSpPr>
+          <p:cNvPr id="3" name="Text Placeholder 2"/>
+          <p:cNvSpPr>
+            <a:spLocks noGrp="1"/>
+          </p:cNvSpPr>
+          <p:nvPr>
+            <p:ph type="body" idx="1"/>
+          </p:nvPr>
+        </p:nvSpPr>
+        <p:spPr/>
+        <p:txBody>
+          <a:bodyPr/>
+          <a:lstStyle/>
+          <a:p>
+            <a:r>
+              <a:rPr lang="pt-BR" sz="2000" dirty="0"/>
+              <a:t>F. Buschmann et al. </a:t>
+            </a:r>
+            <a:r>
+              <a:rPr lang="pt-BR" sz="2000" b="1" dirty="0"/>
+              <a:t>Pattern-Oriented Software Architecture: A System of Patterns</a:t>
+            </a:r>
+            <a:r>
+              <a:rPr lang="pt-BR" sz="2000" dirty="0"/>
+              <a:t>. </a:t>
+            </a:r>
+            <a:r>
+              <a:rPr lang="pt-BR" sz="2000" dirty="0" smtClean="0"/>
+              <a:t>John </a:t>
+            </a:r>
+            <a:r>
+              <a:rPr lang="pt-BR" sz="2000" dirty="0"/>
+              <a:t>Wiley &amp; Sons, 1996. </a:t>
+            </a:r>
+            <a:endParaRPr lang="pt-BR" sz="2000" dirty="0" smtClean="0"/>
+          </a:p>
+          <a:p>
+            <a:pPr lvl="1"/>
+            <a:r>
+              <a:rPr lang="pt-BR" sz="1800" dirty="0" smtClean="0"/>
+              <a:t>Cap</a:t>
+            </a:r>
+            <a:r>
+              <a:rPr lang="pt-BR" sz="1800" dirty="0"/>
+              <a:t>. 4  Idioms</a:t>
+            </a:r>
+          </a:p>
+          <a:p>
+            <a:endParaRPr lang="pt-BR" dirty="0"/>
+          </a:p>
+          <a:p>
+            <a:r>
+              <a:rPr lang="pt-BR" sz="2000" dirty="0"/>
+              <a:t>A. von Staa. </a:t>
+            </a:r>
+            <a:r>
+              <a:rPr lang="pt-BR" sz="2000" b="1" dirty="0"/>
+              <a:t>Programação Modular</a:t>
+            </a:r>
+            <a:r>
+              <a:rPr lang="pt-BR" sz="2000" dirty="0"/>
+              <a:t>. Elsevier, 2000. </a:t>
+            </a:r>
+            <a:endParaRPr lang="pt-BR" sz="2000" dirty="0" smtClean="0"/>
+          </a:p>
+          <a:p>
+            <a:pPr lvl="1"/>
+            <a:r>
+              <a:rPr lang="pt-BR" sz="1800" dirty="0" smtClean="0"/>
+              <a:t>Apêndices </a:t>
+            </a:r>
+            <a:r>
+              <a:rPr lang="pt-BR" sz="1800" dirty="0"/>
+              <a:t>3, 4 e 5 </a:t>
+            </a:r>
           </a:p>
         </p:txBody>
       </p:sp>
@@ -7748,564 +8436,7 @@
     </p:spTree>
     <p:extLst>
       <p:ext uri="{BB962C8B-B14F-4D97-AF65-F5344CB8AC3E}">
-        <p14:creationId xmlns:p14="http://schemas.microsoft.com/office/powerpoint/2010/main" val="4074385538"/>
-      </p:ext>
-    </p:extLst>
-  </p:cSld>
-  <p:clrMapOvr>
-    <a:masterClrMapping/>
-  </p:clrMapOvr>
-</p:sld>
-</file>
-
-<file path=ppt/slides/slide22.xml><?xml version="1.0" encoding="utf-8"?>
-<p:sld xmlns:a="http://schemas.openxmlformats.org/drawingml/2006/main" xmlns:r="http://schemas.openxmlformats.org/officeDocument/2006/relationships" xmlns:p="http://schemas.openxmlformats.org/presentationml/2006/main">
-  <p:cSld>
-    <p:spTree>
-      <p:nvGrpSpPr>
-        <p:cNvPr id="1" name=""/>
-        <p:cNvGrpSpPr/>
-        <p:nvPr/>
-      </p:nvGrpSpPr>
-      <p:grpSpPr>
-        <a:xfrm>
-          <a:off x="0" y="0"/>
-          <a:ext cx="0" cy="0"/>
-          <a:chOff x="0" y="0"/>
-          <a:chExt cx="0" cy="0"/>
-        </a:xfrm>
-      </p:grpSpPr>
-      <p:sp>
-        <p:nvSpPr>
-          <p:cNvPr id="2" name="Title 1"/>
-          <p:cNvSpPr>
-            <a:spLocks noGrp="1"/>
-          </p:cNvSpPr>
-          <p:nvPr>
-            <p:ph type="title"/>
-          </p:nvPr>
-        </p:nvSpPr>
-        <p:spPr>
-          <a:xfrm>
-            <a:off x="311700" y="246254"/>
-            <a:ext cx="8520600" cy="572700"/>
-          </a:xfrm>
-        </p:spPr>
-        <p:txBody>
-          <a:bodyPr/>
-          <a:lstStyle/>
-          <a:p>
-            <a:pPr algn="ctr"/>
-            <a:r>
-              <a:rPr lang="pt-BR" dirty="0" smtClean="0"/>
-              <a:t>GIT</a:t>
-            </a:r>
-            <a:endParaRPr lang="pt-BR" dirty="0"/>
-          </a:p>
-        </p:txBody>
-      </p:sp>
-      <p:sp>
-        <p:nvSpPr>
-          <p:cNvPr id="3" name="Text Placeholder 2"/>
-          <p:cNvSpPr>
-            <a:spLocks noGrp="1"/>
-          </p:cNvSpPr>
-          <p:nvPr>
-            <p:ph type="body" idx="1"/>
-          </p:nvPr>
-        </p:nvSpPr>
-        <p:spPr/>
-        <p:txBody>
-          <a:bodyPr/>
-          <a:lstStyle/>
-          <a:p>
-            <a:r>
-              <a:rPr lang="pt-BR" sz="2000" dirty="0" smtClean="0"/>
-              <a:t>O GIT é um sistema de controle de versão distribuído, projetado e desenvolvido por Linus Torvalds para o desenvolvimento do Kernel do Linux</a:t>
-            </a:r>
-          </a:p>
-          <a:p>
-            <a:endParaRPr lang="pt-BR" sz="2000" dirty="0"/>
-          </a:p>
-          <a:p>
-            <a:r>
-              <a:rPr lang="pt-BR" sz="2000" dirty="0" smtClean="0"/>
-              <a:t>Pode ser utilizado para manter o histórico do projeto de uma equipe de desenvolvedores geograficamente distribuída</a:t>
-            </a:r>
-          </a:p>
-          <a:p>
-            <a:endParaRPr lang="pt-BR" sz="2000" dirty="0"/>
-          </a:p>
-          <a:p>
-            <a:r>
-              <a:rPr lang="pt-BR" sz="2000" dirty="0" smtClean="0"/>
-              <a:t>Propicia rapidez, confiabilidade e trabalho local</a:t>
-            </a:r>
-            <a:endParaRPr lang="pt-BR" sz="2000" dirty="0"/>
-          </a:p>
-        </p:txBody>
-      </p:sp>
-      <p:sp>
-        <p:nvSpPr>
-          <p:cNvPr id="4" name="Slide Number Placeholder 3"/>
-          <p:cNvSpPr>
-            <a:spLocks noGrp="1"/>
-          </p:cNvSpPr>
-          <p:nvPr>
-            <p:ph type="sldNum" idx="12"/>
-          </p:nvPr>
-        </p:nvSpPr>
-        <p:spPr/>
-        <p:txBody>
-          <a:bodyPr/>
-          <a:lstStyle/>
-          <a:p>
-            <a:pPr marL="0" lvl="0" indent="0" algn="r" rtl="0">
-              <a:spcBef>
-                <a:spcPts val="0"/>
-              </a:spcBef>
-              <a:spcAft>
-                <a:spcPts val="0"/>
-              </a:spcAft>
-              <a:buNone/>
-            </a:pPr>
-            <a:fld id="{00000000-1234-1234-1234-123412341234}" type="slidenum">
-              <a:rPr lang="en" smtClean="0"/>
-              <a:t>22</a:t>
-            </a:fld>
-            <a:endParaRPr lang="en"/>
-          </a:p>
-        </p:txBody>
-      </p:sp>
-    </p:spTree>
-    <p:extLst>
-      <p:ext uri="{BB962C8B-B14F-4D97-AF65-F5344CB8AC3E}">
-        <p14:creationId xmlns:p14="http://schemas.microsoft.com/office/powerpoint/2010/main" val="2415382297"/>
-      </p:ext>
-    </p:extLst>
-  </p:cSld>
-  <p:clrMapOvr>
-    <a:masterClrMapping/>
-  </p:clrMapOvr>
-</p:sld>
-</file>
-
-<file path=ppt/slides/slide23.xml><?xml version="1.0" encoding="utf-8"?>
-<p:sld xmlns:a="http://schemas.openxmlformats.org/drawingml/2006/main" xmlns:r="http://schemas.openxmlformats.org/officeDocument/2006/relationships" xmlns:p="http://schemas.openxmlformats.org/presentationml/2006/main">
-  <p:cSld>
-    <p:spTree>
-      <p:nvGrpSpPr>
-        <p:cNvPr id="1" name=""/>
-        <p:cNvGrpSpPr/>
-        <p:nvPr/>
-      </p:nvGrpSpPr>
-      <p:grpSpPr>
-        <a:xfrm>
-          <a:off x="0" y="0"/>
-          <a:ext cx="0" cy="0"/>
-          <a:chOff x="0" y="0"/>
-          <a:chExt cx="0" cy="0"/>
-        </a:xfrm>
-      </p:grpSpPr>
-      <p:sp>
-        <p:nvSpPr>
-          <p:cNvPr id="2" name="Title 1"/>
-          <p:cNvSpPr>
-            <a:spLocks noGrp="1"/>
-          </p:cNvSpPr>
-          <p:nvPr>
-            <p:ph type="title"/>
-          </p:nvPr>
-        </p:nvSpPr>
-        <p:spPr>
-          <a:xfrm>
-            <a:off x="311700" y="195643"/>
-            <a:ext cx="8520600" cy="572700"/>
-          </a:xfrm>
-        </p:spPr>
-        <p:txBody>
-          <a:bodyPr/>
-          <a:lstStyle/>
-          <a:p>
-            <a:pPr algn="ctr"/>
-            <a:r>
-              <a:rPr lang="pt-BR" dirty="0" smtClean="0"/>
-              <a:t>Alguns projetos que utilizam o GIT</a:t>
-            </a:r>
-            <a:endParaRPr lang="pt-BR" dirty="0"/>
-          </a:p>
-        </p:txBody>
-      </p:sp>
-      <p:sp>
-        <p:nvSpPr>
-          <p:cNvPr id="4" name="Slide Number Placeholder 3"/>
-          <p:cNvSpPr>
-            <a:spLocks noGrp="1"/>
-          </p:cNvSpPr>
-          <p:nvPr>
-            <p:ph type="sldNum" idx="12"/>
-          </p:nvPr>
-        </p:nvSpPr>
-        <p:spPr/>
-        <p:txBody>
-          <a:bodyPr/>
-          <a:lstStyle/>
-          <a:p>
-            <a:pPr marL="0" lvl="0" indent="0" algn="r" rtl="0">
-              <a:spcBef>
-                <a:spcPts val="0"/>
-              </a:spcBef>
-              <a:spcAft>
-                <a:spcPts val="0"/>
-              </a:spcAft>
-              <a:buNone/>
-            </a:pPr>
-            <a:fld id="{00000000-1234-1234-1234-123412341234}" type="slidenum">
-              <a:rPr lang="en" smtClean="0"/>
-              <a:t>23</a:t>
-            </a:fld>
-            <a:endParaRPr lang="en"/>
-          </a:p>
-        </p:txBody>
-      </p:sp>
-      <p:pic>
-        <p:nvPicPr>
-          <p:cNvPr id="5" name="Picture 4"/>
-          <p:cNvPicPr>
-            <a:picLocks noChangeAspect="1"/>
-          </p:cNvPicPr>
-          <p:nvPr/>
-        </p:nvPicPr>
-        <p:blipFill>
-          <a:blip r:embed="rId2">
-            <a:extLst>
-              <a:ext uri="{28A0092B-C50C-407E-A947-70E740481C1C}">
-                <a14:useLocalDpi xmlns:a14="http://schemas.microsoft.com/office/drawing/2010/main" val="0"/>
-              </a:ext>
-            </a:extLst>
-          </a:blip>
-          <a:stretch>
-            <a:fillRect/>
-          </a:stretch>
-        </p:blipFill>
-        <p:spPr>
-          <a:xfrm>
-            <a:off x="1550366" y="1067085"/>
-            <a:ext cx="4691107" cy="3708152"/>
-          </a:xfrm>
-          <a:prstGeom prst="rect">
-            <a:avLst/>
-          </a:prstGeom>
-        </p:spPr>
-      </p:pic>
-    </p:spTree>
-    <p:extLst>
-      <p:ext uri="{BB962C8B-B14F-4D97-AF65-F5344CB8AC3E}">
-        <p14:creationId xmlns:p14="http://schemas.microsoft.com/office/powerpoint/2010/main" val="1767429846"/>
-      </p:ext>
-    </p:extLst>
-  </p:cSld>
-  <p:clrMapOvr>
-    <a:masterClrMapping/>
-  </p:clrMapOvr>
-</p:sld>
-</file>
-
-<file path=ppt/slides/slide24.xml><?xml version="1.0" encoding="utf-8"?>
-<p:sld xmlns:a="http://schemas.openxmlformats.org/drawingml/2006/main" xmlns:r="http://schemas.openxmlformats.org/officeDocument/2006/relationships" xmlns:p="http://schemas.openxmlformats.org/presentationml/2006/main">
-  <p:cSld>
-    <p:spTree>
-      <p:nvGrpSpPr>
-        <p:cNvPr id="1" name=""/>
-        <p:cNvGrpSpPr/>
-        <p:nvPr/>
-      </p:nvGrpSpPr>
-      <p:grpSpPr>
-        <a:xfrm>
-          <a:off x="0" y="0"/>
-          <a:ext cx="0" cy="0"/>
-          <a:chOff x="0" y="0"/>
-          <a:chExt cx="0" cy="0"/>
-        </a:xfrm>
-      </p:grpSpPr>
-      <p:sp>
-        <p:nvSpPr>
-          <p:cNvPr id="2" name="Title 1"/>
-          <p:cNvSpPr>
-            <a:spLocks noGrp="1"/>
-          </p:cNvSpPr>
-          <p:nvPr>
-            <p:ph type="title"/>
-          </p:nvPr>
-        </p:nvSpPr>
-        <p:spPr>
-          <a:xfrm>
-            <a:off x="304773" y="209498"/>
-            <a:ext cx="8520600" cy="572700"/>
-          </a:xfrm>
-        </p:spPr>
-        <p:txBody>
-          <a:bodyPr/>
-          <a:lstStyle/>
-          <a:p>
-            <a:pPr algn="ctr"/>
-            <a:r>
-              <a:rPr lang="pt-BR" dirty="0" smtClean="0"/>
-              <a:t>Serviços de hospedagem que suportam o GIT</a:t>
-            </a:r>
-            <a:endParaRPr lang="pt-BR" dirty="0"/>
-          </a:p>
-        </p:txBody>
-      </p:sp>
-      <p:sp>
-        <p:nvSpPr>
-          <p:cNvPr id="4" name="Slide Number Placeholder 3"/>
-          <p:cNvSpPr>
-            <a:spLocks noGrp="1"/>
-          </p:cNvSpPr>
-          <p:nvPr>
-            <p:ph type="sldNum" idx="12"/>
-          </p:nvPr>
-        </p:nvSpPr>
-        <p:spPr/>
-        <p:txBody>
-          <a:bodyPr/>
-          <a:lstStyle/>
-          <a:p>
-            <a:pPr marL="0" lvl="0" indent="0" algn="r" rtl="0">
-              <a:spcBef>
-                <a:spcPts val="0"/>
-              </a:spcBef>
-              <a:spcAft>
-                <a:spcPts val="0"/>
-              </a:spcAft>
-              <a:buNone/>
-            </a:pPr>
-            <a:fld id="{00000000-1234-1234-1234-123412341234}" type="slidenum">
-              <a:rPr lang="en" smtClean="0"/>
-              <a:t>24</a:t>
-            </a:fld>
-            <a:endParaRPr lang="en"/>
-          </a:p>
-        </p:txBody>
-      </p:sp>
-      <p:pic>
-        <p:nvPicPr>
-          <p:cNvPr id="5" name="Picture 4"/>
-          <p:cNvPicPr>
-            <a:picLocks noChangeAspect="1"/>
-          </p:cNvPicPr>
-          <p:nvPr/>
-        </p:nvPicPr>
-        <p:blipFill>
-          <a:blip r:embed="rId2">
-            <a:extLst>
-              <a:ext uri="{28A0092B-C50C-407E-A947-70E740481C1C}">
-                <a14:useLocalDpi xmlns:a14="http://schemas.microsoft.com/office/drawing/2010/main" val="0"/>
-              </a:ext>
-            </a:extLst>
-          </a:blip>
-          <a:stretch>
-            <a:fillRect/>
-          </a:stretch>
-        </p:blipFill>
-        <p:spPr>
-          <a:xfrm>
-            <a:off x="304773" y="1038449"/>
-            <a:ext cx="5909642" cy="3821568"/>
-          </a:xfrm>
-          <a:prstGeom prst="rect">
-            <a:avLst/>
-          </a:prstGeom>
-        </p:spPr>
-      </p:pic>
-    </p:spTree>
-    <p:extLst>
-      <p:ext uri="{BB962C8B-B14F-4D97-AF65-F5344CB8AC3E}">
-        <p14:creationId xmlns:p14="http://schemas.microsoft.com/office/powerpoint/2010/main" val="2969229364"/>
-      </p:ext>
-    </p:extLst>
-  </p:cSld>
-  <p:clrMapOvr>
-    <a:masterClrMapping/>
-  </p:clrMapOvr>
-</p:sld>
-</file>
-
-<file path=ppt/slides/slide25.xml><?xml version="1.0" encoding="utf-8"?>
-<p:sld xmlns:a="http://schemas.openxmlformats.org/drawingml/2006/main" xmlns:r="http://schemas.openxmlformats.org/officeDocument/2006/relationships" xmlns:p="http://schemas.openxmlformats.org/presentationml/2006/main">
-  <p:cSld>
-    <p:spTree>
-      <p:nvGrpSpPr>
-        <p:cNvPr id="1" name=""/>
-        <p:cNvGrpSpPr/>
-        <p:nvPr/>
-      </p:nvGrpSpPr>
-      <p:grpSpPr>
-        <a:xfrm>
-          <a:off x="0" y="0"/>
-          <a:ext cx="0" cy="0"/>
-          <a:chOff x="0" y="0"/>
-          <a:chExt cx="0" cy="0"/>
-        </a:xfrm>
-      </p:grpSpPr>
-      <p:sp>
-        <p:nvSpPr>
-          <p:cNvPr id="2" name="Title 1"/>
-          <p:cNvSpPr>
-            <a:spLocks noGrp="1"/>
-          </p:cNvSpPr>
-          <p:nvPr>
-            <p:ph type="title"/>
-          </p:nvPr>
-        </p:nvSpPr>
-        <p:spPr>
-          <a:xfrm>
-            <a:off x="311700" y="244135"/>
-            <a:ext cx="8520600" cy="572700"/>
-          </a:xfrm>
-        </p:spPr>
-        <p:txBody>
-          <a:bodyPr/>
-          <a:lstStyle/>
-          <a:p>
-            <a:pPr algn="ctr"/>
-            <a:r>
-              <a:rPr lang="pt-BR" dirty="0" smtClean="0"/>
-              <a:t>Bibliografia</a:t>
-            </a:r>
-            <a:endParaRPr lang="pt-BR" dirty="0"/>
-          </a:p>
-        </p:txBody>
-      </p:sp>
-      <p:sp>
-        <p:nvSpPr>
-          <p:cNvPr id="3" name="Text Placeholder 2"/>
-          <p:cNvSpPr>
-            <a:spLocks noGrp="1"/>
-          </p:cNvSpPr>
-          <p:nvPr>
-            <p:ph type="body" idx="1"/>
-          </p:nvPr>
-        </p:nvSpPr>
-        <p:spPr>
-          <a:xfrm>
-            <a:off x="311700" y="1031826"/>
-            <a:ext cx="8520600" cy="3865756"/>
-          </a:xfrm>
-        </p:spPr>
-        <p:txBody>
-          <a:bodyPr/>
-          <a:lstStyle/>
-          <a:p>
-            <a:r>
-              <a:rPr lang="pt-BR" sz="2000" dirty="0"/>
-              <a:t>Marco Tulio Valente. </a:t>
-            </a:r>
-            <a:r>
-              <a:rPr lang="pt-BR" sz="2000" b="1" dirty="0"/>
-              <a:t>Engenharia de Software Moderna: Princípios e Práticas para Desenvolvimento de Software com </a:t>
-            </a:r>
-            <a:r>
-              <a:rPr lang="pt-BR" sz="2000" b="1" dirty="0" smtClean="0"/>
-              <a:t>Produtividade</a:t>
-            </a:r>
-            <a:r>
-              <a:rPr lang="pt-BR" sz="2000" dirty="0" smtClean="0"/>
-              <a:t>. Leanpub</a:t>
-            </a:r>
-            <a:r>
-              <a:rPr lang="pt-BR" sz="2000" dirty="0"/>
-              <a:t>, 2020</a:t>
-            </a:r>
-            <a:r>
-              <a:rPr lang="pt-BR" sz="2000" dirty="0" smtClean="0"/>
-              <a:t>.</a:t>
-            </a:r>
-          </a:p>
-          <a:p>
-            <a:pPr lvl="1"/>
-            <a:r>
-              <a:rPr lang="pt-BR" sz="1600" dirty="0" smtClean="0"/>
-              <a:t>Apêndice A: GIT</a:t>
-            </a:r>
-          </a:p>
-          <a:p>
-            <a:pPr lvl="1"/>
-            <a:endParaRPr lang="pt-BR" sz="1600" dirty="0"/>
-          </a:p>
-          <a:p>
-            <a:pPr lvl="1"/>
-            <a:endParaRPr lang="pt-BR" sz="1600" dirty="0" smtClean="0"/>
-          </a:p>
-        </p:txBody>
-      </p:sp>
-      <p:sp>
-        <p:nvSpPr>
-          <p:cNvPr id="4" name="Slide Number Placeholder 3"/>
-          <p:cNvSpPr>
-            <a:spLocks noGrp="1"/>
-          </p:cNvSpPr>
-          <p:nvPr>
-            <p:ph type="sldNum" idx="12"/>
-          </p:nvPr>
-        </p:nvSpPr>
-        <p:spPr/>
-        <p:txBody>
-          <a:bodyPr/>
-          <a:lstStyle/>
-          <a:p>
-            <a:pPr marL="0" lvl="0" indent="0" algn="r" rtl="0">
-              <a:spcBef>
-                <a:spcPts val="0"/>
-              </a:spcBef>
-              <a:spcAft>
-                <a:spcPts val="0"/>
-              </a:spcAft>
-              <a:buNone/>
-            </a:pPr>
-            <a:fld id="{00000000-1234-1234-1234-123412341234}" type="slidenum">
-              <a:rPr lang="en" smtClean="0"/>
-              <a:t>25</a:t>
-            </a:fld>
-            <a:endParaRPr lang="en"/>
-          </a:p>
-        </p:txBody>
-      </p:sp>
-      <p:pic>
-        <p:nvPicPr>
-          <p:cNvPr id="5" name="Picture 4"/>
-          <p:cNvPicPr>
-            <a:picLocks noChangeAspect="1"/>
-          </p:cNvPicPr>
-          <p:nvPr/>
-        </p:nvPicPr>
-        <p:blipFill>
-          <a:blip r:embed="rId2">
-            <a:extLst>
-              <a:ext uri="{28A0092B-C50C-407E-A947-70E740481C1C}">
-                <a14:useLocalDpi xmlns:a14="http://schemas.microsoft.com/office/drawing/2010/main" val="0"/>
-              </a:ext>
-            </a:extLst>
-          </a:blip>
-          <a:stretch>
-            <a:fillRect/>
-          </a:stretch>
-        </p:blipFill>
-        <p:spPr>
-          <a:xfrm>
-            <a:off x="3811629" y="2470810"/>
-            <a:ext cx="1619351" cy="2389207"/>
-          </a:xfrm>
-          <a:prstGeom prst="rect">
-            <a:avLst/>
-          </a:prstGeom>
-        </p:spPr>
-      </p:pic>
-    </p:spTree>
-    <p:extLst>
-      <p:ext uri="{BB962C8B-B14F-4D97-AF65-F5344CB8AC3E}">
-        <p14:creationId xmlns:p14="http://schemas.microsoft.com/office/powerpoint/2010/main" val="2975580456"/>
+        <p14:creationId xmlns:p14="http://schemas.microsoft.com/office/powerpoint/2010/main" val="2488993648"/>
       </p:ext>
     </p:extLst>
   </p:cSld>
@@ -8344,7 +8475,7 @@
         </p:nvSpPr>
         <p:spPr>
           <a:xfrm>
-            <a:off x="311700" y="246253"/>
+            <a:off x="311700" y="246254"/>
             <a:ext cx="8520600" cy="572700"/>
           </a:xfrm>
         </p:spPr>
@@ -8355,7 +8486,7 @@
             <a:pPr algn="ctr"/>
             <a:r>
               <a:rPr lang="pt-BR" dirty="0" smtClean="0"/>
-              <a:t>Funcionamento de um SCV</a:t>
+              <a:t>Idiomas e Estilos</a:t>
             </a:r>
             <a:endParaRPr lang="pt-BR" dirty="0"/>
           </a:p>
@@ -8371,15 +8502,35 @@
             <p:ph type="body" idx="1"/>
           </p:nvPr>
         </p:nvSpPr>
-        <p:spPr>
-          <a:xfrm>
-            <a:off x="311700" y="1032885"/>
-            <a:ext cx="8520600" cy="3416400"/>
-          </a:xfrm>
-        </p:spPr>
+        <p:spPr/>
         <p:txBody>
           <a:bodyPr/>
           <a:lstStyle/>
+          <a:p>
+            <a:r>
+              <a:rPr lang="pt-BR" sz="2000" dirty="0" smtClean="0"/>
+              <a:t>Um conjunto de idiomas definem um estilo de programação</a:t>
+            </a:r>
+          </a:p>
+          <a:p>
+            <a:pPr lvl="1">
+              <a:lnSpc>
+                <a:spcPct val="100000"/>
+              </a:lnSpc>
+            </a:pPr>
+            <a:r>
+              <a:rPr lang="pt-BR" sz="1800" dirty="0" smtClean="0"/>
+              <a:t>O estilo de programação é definido pela forma como são usadas as construções da linguagem</a:t>
+            </a:r>
+          </a:p>
+          <a:p>
+            <a:pPr lvl="1">
+              <a:lnSpc>
+                <a:spcPct val="100000"/>
+              </a:lnSpc>
+            </a:pPr>
+            <a:endParaRPr lang="pt-BR" sz="1800" dirty="0" smtClean="0"/>
+          </a:p>
           <a:p>
             <a:pPr>
               <a:lnSpc>
@@ -8388,55 +8539,56 @@
             </a:pPr>
             <a:r>
               <a:rPr lang="pt-BR" sz="2000" dirty="0" smtClean="0"/>
-              <a:t>Basicamente, os arquivos do projeto ficam armazenados em um repositório (servidor) e o histórico de suas versões é salvo nele</a:t>
-            </a:r>
-          </a:p>
-          <a:p>
-            <a:pPr>
+              <a:t>Exemplos de idiomas</a:t>
+            </a:r>
+            <a:endParaRPr lang="pt-BR" sz="2000" dirty="0"/>
+          </a:p>
+          <a:p>
+            <a:pPr lvl="1">
               <a:lnSpc>
                 <a:spcPct val="100000"/>
               </a:lnSpc>
             </a:pPr>
-            <a:endParaRPr lang="pt-BR" sz="2000" dirty="0"/>
-          </a:p>
-          <a:p>
-            <a:pPr>
+            <a:r>
+              <a:rPr lang="pt-BR" sz="1800" dirty="0" smtClean="0"/>
+              <a:t> A forma como os loops são usados</a:t>
+            </a:r>
+          </a:p>
+          <a:p>
+            <a:pPr lvl="1">
               <a:lnSpc>
                 <a:spcPct val="100000"/>
               </a:lnSpc>
             </a:pPr>
             <a:r>
-              <a:rPr lang="pt-BR" sz="2000" dirty="0" smtClean="0"/>
-              <a:t>Os desenvolvedores podem acessar e resgatar a última versão disponível e fazer uma cópia local</a:t>
-            </a:r>
-          </a:p>
-          <a:p>
-            <a:pPr>
+              <a:rPr lang="pt-BR" sz="1800" dirty="0" smtClean="0"/>
+              <a:t>O formato de nomes</a:t>
+            </a:r>
+          </a:p>
+          <a:p>
+            <a:pPr lvl="1">
               <a:lnSpc>
                 <a:spcPct val="100000"/>
               </a:lnSpc>
             </a:pPr>
-            <a:endParaRPr lang="pt-BR" sz="2000" dirty="0"/>
-          </a:p>
-          <a:p>
-            <a:pPr>
-              <a:lnSpc>
-                <a:spcPct val="100000"/>
-              </a:lnSpc>
+            <a:r>
+              <a:rPr lang="pt-BR" sz="1800" dirty="0" smtClean="0"/>
+              <a:t>A formatação do código-fonte</a:t>
+            </a:r>
+            <a:endParaRPr lang="pt-BR" sz="1800" dirty="0"/>
+          </a:p>
+          <a:p>
+            <a:pPr marL="596900" lvl="1" indent="0">
+              <a:buNone/>
             </a:pPr>
-            <a:r>
-              <a:rPr lang="pt-BR" sz="2000" dirty="0" smtClean="0"/>
-              <a:t>A cada alteração feita, é possível enviar novamente ao servidor e atualizar a sua versão com as alterações feitas por outros </a:t>
-            </a:r>
-            <a:r>
-              <a:rPr lang="pt-BR" sz="2000" i="1" dirty="0" smtClean="0"/>
-              <a:t>developers</a:t>
-            </a:r>
-          </a:p>
-          <a:p>
+            <a:endParaRPr lang="pt-BR" sz="1800" dirty="0" smtClean="0"/>
+          </a:p>
+          <a:p>
+            <a:pPr lvl="1"/>
             <a:endParaRPr lang="pt-BR" dirty="0"/>
           </a:p>
           <a:p>
+            <a:pPr lvl="1"/>
             <a:endParaRPr lang="pt-BR" dirty="0"/>
           </a:p>
         </p:txBody>
@@ -8476,7 +8628,7 @@
     </p:spTree>
     <p:extLst>
       <p:ext uri="{BB962C8B-B14F-4D97-AF65-F5344CB8AC3E}">
-        <p14:creationId xmlns:p14="http://schemas.microsoft.com/office/powerpoint/2010/main" val="1676882620"/>
+        <p14:creationId xmlns:p14="http://schemas.microsoft.com/office/powerpoint/2010/main" val="3095144631"/>
       </p:ext>
     </p:extLst>
   </p:cSld>
@@ -8515,18 +8667,17 @@
         </p:nvSpPr>
         <p:spPr>
           <a:xfrm>
-            <a:off x="311700" y="313408"/>
-            <a:ext cx="8520600" cy="572700"/>
+            <a:off x="3047971" y="1927462"/>
+            <a:ext cx="3463665" cy="572700"/>
           </a:xfrm>
         </p:spPr>
         <p:txBody>
           <a:bodyPr/>
           <a:lstStyle/>
           <a:p>
-            <a:pPr algn="ctr"/>
             <a:r>
               <a:rPr lang="pt-BR" dirty="0" smtClean="0"/>
-              <a:t>Funcionamento de um SCV</a:t>
+              <a:t>Idiomas em Java</a:t>
             </a:r>
             <a:endParaRPr lang="pt-BR" dirty="0"/>
           </a:p>
@@ -8564,40 +8715,10 @@
           </a:p>
         </p:txBody>
       </p:sp>
-      <p:pic>
-        <p:nvPicPr>
-          <p:cNvPr id="7" name="Picture 6"/>
-          <p:cNvPicPr>
-            <a:picLocks noChangeAspect="1"/>
-          </p:cNvPicPr>
-          <p:nvPr/>
-        </p:nvPicPr>
-        <p:blipFill>
-          <a:blip r:embed="rId2">
-            <a:extLst>
-              <a:ext uri="{28A0092B-C50C-407E-A947-70E740481C1C}">
-                <a14:useLocalDpi xmlns:a14="http://schemas.microsoft.com/office/drawing/2010/main" val="0"/>
-              </a:ext>
-            </a:extLst>
-          </a:blip>
-          <a:stretch>
-            <a:fillRect/>
-          </a:stretch>
-        </p:blipFill>
-        <p:spPr>
-          <a:xfrm>
-            <a:off x="433064" y="1396182"/>
-            <a:ext cx="5448191" cy="3296193"/>
-          </a:xfrm>
-          <a:prstGeom prst="rect">
-            <a:avLst/>
-          </a:prstGeom>
-        </p:spPr>
-      </p:pic>
     </p:spTree>
     <p:extLst>
       <p:ext uri="{BB962C8B-B14F-4D97-AF65-F5344CB8AC3E}">
-        <p14:creationId xmlns:p14="http://schemas.microsoft.com/office/powerpoint/2010/main" val="2414082927"/>
+        <p14:creationId xmlns:p14="http://schemas.microsoft.com/office/powerpoint/2010/main" val="4181634343"/>
       </p:ext>
     </p:extLst>
   </p:cSld>
@@ -8647,7 +8768,7 @@
             <a:pPr algn="ctr"/>
             <a:r>
               <a:rPr lang="pt-BR" dirty="0" smtClean="0"/>
-              <a:t>Classificação</a:t>
+              <a:t>Idioma e Recomendação</a:t>
             </a:r>
             <a:endParaRPr lang="pt-BR" dirty="0"/>
           </a:p>
@@ -8669,8 +8790,8 @@
           <a:lstStyle/>
           <a:p>
             <a:r>
-              <a:rPr lang="pt-BR" dirty="0" smtClean="0"/>
-              <a:t>Atualmente, os SCVs são classificados em dois tipos:</a:t>
+              <a:rPr lang="pt-BR" sz="2000" dirty="0" smtClean="0"/>
+              <a:t>Muitos dos idiomas são, na verdade, recomendação sobre o uso de construções da linguagem</a:t>
             </a:r>
           </a:p>
           <a:p>
@@ -8678,19 +8799,25 @@
           </a:p>
           <a:p>
             <a:r>
-              <a:rPr lang="pt-BR" dirty="0" smtClean="0"/>
-              <a:t>Centralizados</a:t>
-            </a:r>
-          </a:p>
-          <a:p>
-            <a:endParaRPr lang="pt-BR" dirty="0"/>
-          </a:p>
-          <a:p>
-            <a:r>
-              <a:rPr lang="pt-BR" dirty="0" smtClean="0"/>
-              <a:t>Distribuídos</a:t>
-            </a:r>
-            <a:endParaRPr lang="pt-BR" dirty="0"/>
+              <a:rPr lang="pt-BR" sz="2000" dirty="0" smtClean="0"/>
+              <a:t>Outros idiomas dizem como implementar um padrão de projeto usando uma linguagem</a:t>
+            </a:r>
+          </a:p>
+          <a:p>
+            <a:pPr lvl="1"/>
+            <a:r>
+              <a:rPr lang="pt-BR" sz="1800" dirty="0" smtClean="0"/>
+              <a:t>Exemplo: como implementar o padrão </a:t>
+            </a:r>
+            <a:r>
+              <a:rPr lang="pt-BR" sz="1800" i="1" dirty="0" smtClean="0"/>
+              <a:t>Adapter</a:t>
+            </a:r>
+            <a:r>
+              <a:rPr lang="pt-BR" sz="1800" dirty="0" smtClean="0"/>
+              <a:t> em Java</a:t>
+            </a:r>
+            <a:endParaRPr lang="pt-BR" sz="1800" dirty="0"/>
           </a:p>
         </p:txBody>
       </p:sp>
@@ -8726,40 +8853,10 @@
           </a:p>
         </p:txBody>
       </p:sp>
-      <p:pic>
-        <p:nvPicPr>
-          <p:cNvPr id="5" name="Picture 4"/>
-          <p:cNvPicPr>
-            <a:picLocks noChangeAspect="1"/>
-          </p:cNvPicPr>
-          <p:nvPr/>
-        </p:nvPicPr>
-        <p:blipFill>
-          <a:blip r:embed="rId2">
-            <a:extLst>
-              <a:ext uri="{28A0092B-C50C-407E-A947-70E740481C1C}">
-                <a14:useLocalDpi xmlns:a14="http://schemas.microsoft.com/office/drawing/2010/main" val="0"/>
-              </a:ext>
-            </a:extLst>
-          </a:blip>
-          <a:stretch>
-            <a:fillRect/>
-          </a:stretch>
-        </p:blipFill>
-        <p:spPr>
-          <a:xfrm>
-            <a:off x="2677998" y="1790113"/>
-            <a:ext cx="3552476" cy="2141123"/>
-          </a:xfrm>
-          <a:prstGeom prst="rect">
-            <a:avLst/>
-          </a:prstGeom>
-        </p:spPr>
-      </p:pic>
     </p:spTree>
     <p:extLst>
       <p:ext uri="{BB962C8B-B14F-4D97-AF65-F5344CB8AC3E}">
-        <p14:creationId xmlns:p14="http://schemas.microsoft.com/office/powerpoint/2010/main" val="32663216"/>
+        <p14:creationId xmlns:p14="http://schemas.microsoft.com/office/powerpoint/2010/main" val="248475736"/>
       </p:ext>
     </p:extLst>
   </p:cSld>
@@ -8798,7 +8895,7 @@
         </p:nvSpPr>
         <p:spPr>
           <a:xfrm>
-            <a:off x="311700" y="246254"/>
+            <a:off x="311700" y="278771"/>
             <a:ext cx="8520600" cy="572700"/>
           </a:xfrm>
         </p:spPr>
@@ -8809,7 +8906,7 @@
             <a:pPr algn="ctr"/>
             <a:r>
               <a:rPr lang="pt-BR" dirty="0" smtClean="0"/>
-              <a:t>SCVs Centralizados</a:t>
+              <a:t>Uma Classe por Arquivo</a:t>
             </a:r>
             <a:endParaRPr lang="pt-BR" dirty="0"/>
           </a:p>
@@ -8825,33 +8922,46 @@
             <p:ph type="body" idx="1"/>
           </p:nvPr>
         </p:nvSpPr>
-        <p:spPr/>
+        <p:spPr>
+          <a:xfrm>
+            <a:off x="311700" y="1152475"/>
+            <a:ext cx="8520600" cy="3904342"/>
+          </a:xfrm>
+        </p:spPr>
         <p:txBody>
           <a:bodyPr/>
           <a:lstStyle/>
           <a:p>
             <a:r>
               <a:rPr lang="pt-BR" sz="2000" dirty="0" smtClean="0"/>
-              <a:t>Um SCV </a:t>
-            </a:r>
-            <a:r>
-              <a:rPr lang="pt-BR" sz="2000" b="1" dirty="0" smtClean="0"/>
-              <a:t>centralizado </a:t>
-            </a:r>
+              <a:t>Deve-se declarar uma única classe por arquivo Java</a:t>
+            </a:r>
+          </a:p>
+          <a:p>
+            <a:pPr lvl="1"/>
+            <a:r>
+              <a:rPr lang="pt-BR" sz="1800" dirty="0" smtClean="0"/>
+              <a:t>A única classe do arquivo deve ser pública para que outras classes tenham acesso</a:t>
+            </a:r>
+          </a:p>
+          <a:p>
+            <a:pPr marL="596900" lvl="1" indent="0">
+              <a:buNone/>
+            </a:pPr>
+            <a:endParaRPr lang="pt-BR" dirty="0"/>
+          </a:p>
+          <a:p>
             <a:r>
               <a:rPr lang="pt-BR" sz="2000" dirty="0" smtClean="0"/>
-              <a:t>trabalha apenas com um servidor central e diversas áreas de trabalho, baseados na arquitetura cliente-servidor</a:t>
+              <a:t>Exemplo:</a:t>
             </a:r>
           </a:p>
           <a:p>
             <a:endParaRPr lang="pt-BR" dirty="0"/>
           </a:p>
           <a:p>
-            <a:r>
-              <a:rPr lang="pt-BR" sz="2000" dirty="0" smtClean="0"/>
-              <a:t>Essa versão atende muito bem a maioria das equipes de desenvolvimento de pequeno e médio porte, e que trabalhem em uma rede local</a:t>
-            </a:r>
-            <a:endParaRPr lang="pt-BR" sz="2000" dirty="0"/>
+            <a:pPr lvl="1"/>
+            <a:endParaRPr lang="pt-BR" dirty="0" smtClean="0"/>
           </a:p>
         </p:txBody>
       </p:sp>
@@ -8887,10 +8997,70 @@
           </a:p>
         </p:txBody>
       </p:sp>
+      <p:pic>
+        <p:nvPicPr>
+          <p:cNvPr id="5" name="Picture 4"/>
+          <p:cNvPicPr>
+            <a:picLocks noChangeAspect="1"/>
+          </p:cNvPicPr>
+          <p:nvPr/>
+        </p:nvPicPr>
+        <p:blipFill>
+          <a:blip r:embed="rId2">
+            <a:extLst>
+              <a:ext uri="{28A0092B-C50C-407E-A947-70E740481C1C}">
+                <a14:useLocalDpi xmlns:a14="http://schemas.microsoft.com/office/drawing/2010/main" val="0"/>
+              </a:ext>
+            </a:extLst>
+          </a:blip>
+          <a:stretch>
+            <a:fillRect/>
+          </a:stretch>
+        </p:blipFill>
+        <p:spPr>
+          <a:xfrm>
+            <a:off x="546215" y="3225316"/>
+            <a:ext cx="5712915" cy="1781447"/>
+          </a:xfrm>
+          <a:prstGeom prst="rect">
+            <a:avLst/>
+          </a:prstGeom>
+        </p:spPr>
+      </p:pic>
+      <p:pic>
+        <p:nvPicPr>
+          <p:cNvPr id="6" name="Picture 5"/>
+          <p:cNvPicPr>
+            <a:picLocks noChangeAspect="1"/>
+          </p:cNvPicPr>
+          <p:nvPr/>
+        </p:nvPicPr>
+        <p:blipFill>
+          <a:blip r:embed="rId3">
+            <a:extLst>
+              <a:ext uri="{28A0092B-C50C-407E-A947-70E740481C1C}">
+                <a14:useLocalDpi xmlns:a14="http://schemas.microsoft.com/office/drawing/2010/main" val="0"/>
+              </a:ext>
+            </a:extLst>
+          </a:blip>
+          <a:stretch>
+            <a:fillRect/>
+          </a:stretch>
+        </p:blipFill>
+        <p:spPr>
+          <a:xfrm>
+            <a:off x="7090028" y="1152475"/>
+            <a:ext cx="638314" cy="539665"/>
+          </a:xfrm>
+          <a:prstGeom prst="rect">
+            <a:avLst/>
+          </a:prstGeom>
+        </p:spPr>
+      </p:pic>
     </p:spTree>
     <p:extLst>
       <p:ext uri="{BB962C8B-B14F-4D97-AF65-F5344CB8AC3E}">
-        <p14:creationId xmlns:p14="http://schemas.microsoft.com/office/powerpoint/2010/main" val="2040040024"/>
+        <p14:creationId xmlns:p14="http://schemas.microsoft.com/office/powerpoint/2010/main" val="3327825529"/>
       </p:ext>
     </p:extLst>
   </p:cSld>
@@ -8929,7 +9099,7 @@
         </p:nvSpPr>
         <p:spPr>
           <a:xfrm>
-            <a:off x="297845" y="202571"/>
+            <a:off x="311700" y="299552"/>
             <a:ext cx="8520600" cy="572700"/>
           </a:xfrm>
         </p:spPr>
@@ -8940,9 +9110,82 @@
             <a:pPr algn="ctr"/>
             <a:r>
               <a:rPr lang="pt-BR" dirty="0" smtClean="0"/>
-              <a:t>Arquitetura de um SCV centralizado</a:t>
+              <a:t>O Método Main</a:t>
             </a:r>
             <a:endParaRPr lang="pt-BR" dirty="0"/>
+          </a:p>
+        </p:txBody>
+      </p:sp>
+      <p:sp>
+        <p:nvSpPr>
+          <p:cNvPr id="3" name="Text Placeholder 2"/>
+          <p:cNvSpPr>
+            <a:spLocks noGrp="1"/>
+          </p:cNvSpPr>
+          <p:nvPr>
+            <p:ph type="body" idx="1"/>
+          </p:nvPr>
+        </p:nvSpPr>
+        <p:spPr>
+          <a:xfrm>
+            <a:off x="311700" y="1063295"/>
+            <a:ext cx="8520600" cy="3835161"/>
+          </a:xfrm>
+        </p:spPr>
+        <p:txBody>
+          <a:bodyPr/>
+          <a:lstStyle/>
+          <a:p>
+            <a:r>
+              <a:rPr lang="pt-BR" sz="2000" dirty="0" smtClean="0"/>
+              <a:t>Deve-se colocar o método </a:t>
+            </a:r>
+            <a:r>
+              <a:rPr lang="pt-BR" sz="2000" i="1" dirty="0" smtClean="0"/>
+              <a:t>main</a:t>
+            </a:r>
+            <a:r>
+              <a:rPr lang="pt-BR" sz="2000" dirty="0" smtClean="0"/>
+              <a:t>() em uma classe separada</a:t>
+            </a:r>
+          </a:p>
+          <a:p>
+            <a:pPr lvl="1"/>
+            <a:r>
+              <a:rPr lang="pt-BR" sz="1800" dirty="0" smtClean="0"/>
+              <a:t>Apenas código de iniciação do sistema deve estar na classe que contém o método </a:t>
+            </a:r>
+            <a:r>
+              <a:rPr lang="pt-BR" sz="1800" i="1" dirty="0" smtClean="0"/>
+              <a:t>main</a:t>
+            </a:r>
+            <a:r>
+              <a:rPr lang="pt-BR" sz="1800" dirty="0" smtClean="0"/>
+              <a:t>()</a:t>
+            </a:r>
+          </a:p>
+          <a:p>
+            <a:pPr lvl="1"/>
+            <a:endParaRPr lang="pt-BR" sz="1800" dirty="0"/>
+          </a:p>
+          <a:p>
+            <a:r>
+              <a:rPr lang="pt-BR" sz="2000" dirty="0" smtClean="0"/>
+              <a:t>Exemplo:</a:t>
+            </a:r>
+            <a:endParaRPr lang="pt-BR" sz="1800" dirty="0" smtClean="0"/>
+          </a:p>
+          <a:p>
+            <a:pPr lvl="1"/>
+            <a:endParaRPr lang="pt-BR" sz="1800" dirty="0"/>
+          </a:p>
+          <a:p>
+            <a:pPr lvl="1"/>
+            <a:endParaRPr lang="pt-BR" sz="1800" dirty="0" smtClean="0"/>
+          </a:p>
+          <a:p>
+            <a:pPr lvl="1"/>
+            <a:endParaRPr lang="pt-BR" sz="1800" dirty="0"/>
           </a:p>
         </p:txBody>
       </p:sp>
@@ -8980,7 +9223,7 @@
       </p:sp>
       <p:pic>
         <p:nvPicPr>
-          <p:cNvPr id="3" name="Picture 2"/>
+          <p:cNvPr id="5" name="Picture 4"/>
           <p:cNvPicPr>
             <a:picLocks noChangeAspect="1"/>
           </p:cNvPicPr>
@@ -9000,8 +9243,68 @@
         </p:blipFill>
         <p:spPr>
           <a:xfrm>
-            <a:off x="180082" y="980061"/>
-            <a:ext cx="5742737" cy="4076756"/>
+            <a:off x="374045" y="3372285"/>
+            <a:ext cx="5930121" cy="1487732"/>
+          </a:xfrm>
+          <a:prstGeom prst="rect">
+            <a:avLst/>
+          </a:prstGeom>
+        </p:spPr>
+      </p:pic>
+      <p:pic>
+        <p:nvPicPr>
+          <p:cNvPr id="6" name="Picture 5"/>
+          <p:cNvPicPr>
+            <a:picLocks noChangeAspect="1"/>
+          </p:cNvPicPr>
+          <p:nvPr/>
+        </p:nvPicPr>
+        <p:blipFill>
+          <a:blip r:embed="rId3">
+            <a:extLst>
+              <a:ext uri="{28A0092B-C50C-407E-A947-70E740481C1C}">
+                <a14:useLocalDpi xmlns:a14="http://schemas.microsoft.com/office/drawing/2010/main" val="0"/>
+              </a:ext>
+            </a:extLst>
+          </a:blip>
+          <a:stretch>
+            <a:fillRect/>
+          </a:stretch>
+        </p:blipFill>
+        <p:spPr>
+          <a:xfrm>
+            <a:off x="7758856" y="1132567"/>
+            <a:ext cx="616217" cy="480536"/>
+          </a:xfrm>
+          <a:prstGeom prst="rect">
+            <a:avLst/>
+          </a:prstGeom>
+        </p:spPr>
+      </p:pic>
+      <p:pic>
+        <p:nvPicPr>
+          <p:cNvPr id="7" name="Picture 6"/>
+          <p:cNvPicPr>
+            <a:picLocks noChangeAspect="1"/>
+          </p:cNvPicPr>
+          <p:nvPr/>
+        </p:nvPicPr>
+        <p:blipFill>
+          <a:blip r:embed="rId4">
+            <a:extLst>
+              <a:ext uri="{28A0092B-C50C-407E-A947-70E740481C1C}">
+                <a14:useLocalDpi xmlns:a14="http://schemas.microsoft.com/office/drawing/2010/main" val="0"/>
+              </a:ext>
+            </a:extLst>
+          </a:blip>
+          <a:stretch>
+            <a:fillRect/>
+          </a:stretch>
+        </p:blipFill>
+        <p:spPr>
+          <a:xfrm>
+            <a:off x="3172315" y="2099283"/>
+            <a:ext cx="628991" cy="498445"/>
           </a:xfrm>
           <a:prstGeom prst="rect">
             <a:avLst/>
@@ -9011,7 +9314,7 @@
     </p:spTree>
     <p:extLst>
       <p:ext uri="{BB962C8B-B14F-4D97-AF65-F5344CB8AC3E}">
-        <p14:creationId xmlns:p14="http://schemas.microsoft.com/office/powerpoint/2010/main" val="3215690354"/>
+        <p14:creationId xmlns:p14="http://schemas.microsoft.com/office/powerpoint/2010/main" val="1793850745"/>
       </p:ext>
     </p:extLst>
   </p:cSld>
@@ -9048,7 +9351,12 @@
             <p:ph type="title"/>
           </p:nvPr>
         </p:nvSpPr>
-        <p:spPr/>
+        <p:spPr>
+          <a:xfrm>
+            <a:off x="311700" y="246254"/>
+            <a:ext cx="8520600" cy="572700"/>
+          </a:xfrm>
+        </p:spPr>
         <p:txBody>
           <a:bodyPr/>
           <a:lstStyle/>
@@ -9056,7 +9364,7 @@
             <a:pPr algn="ctr"/>
             <a:r>
               <a:rPr lang="pt-BR" dirty="0" smtClean="0"/>
-              <a:t>SCVs Distribuídos</a:t>
+              <a:t>Ocultando Atributos</a:t>
             </a:r>
             <a:endParaRPr lang="pt-BR" dirty="0"/>
           </a:p>
@@ -9072,34 +9380,51 @@
             <p:ph type="body" idx="1"/>
           </p:nvPr>
         </p:nvSpPr>
-        <p:spPr/>
+        <p:spPr>
+          <a:xfrm>
+            <a:off x="311700" y="1152474"/>
+            <a:ext cx="8520600" cy="3800525"/>
+          </a:xfrm>
+        </p:spPr>
         <p:txBody>
           <a:bodyPr/>
           <a:lstStyle/>
           <a:p>
             <a:r>
               <a:rPr lang="pt-BR" sz="2000" dirty="0" smtClean="0"/>
-              <a:t>Um SCV distribuído é recomendado para equipes com muitos desenvolvedores e que se encontram em diferentes locais</a:t>
-            </a:r>
-          </a:p>
-          <a:p>
-            <a:endParaRPr lang="pt-BR" sz="2000" dirty="0"/>
-          </a:p>
-          <a:p>
-            <a:r>
-              <a:rPr lang="pt-BR" sz="2000" dirty="0" smtClean="0"/>
-              <a:t>Esta versão funciona da seguinte maneira: cada área de trabalho tem seu próprio servidor, ou seja, as operações de check-in e check-out são feitas na própria máquina</a:t>
-            </a:r>
-          </a:p>
-          <a:p>
-            <a:endParaRPr lang="pt-BR" sz="2000" dirty="0"/>
-          </a:p>
-          <a:p>
-            <a:r>
-              <a:rPr lang="pt-BR" sz="2000" dirty="0" smtClean="0"/>
-              <a:t>As áreas de trabalho podem se comunicar</a:t>
-            </a:r>
-            <a:endParaRPr lang="pt-BR" sz="2000" dirty="0"/>
+              <a:t>Atributos devem ser privados ou protegidos</a:t>
+            </a:r>
+          </a:p>
+          <a:p>
+            <a:pPr lvl="1"/>
+            <a:r>
+              <a:rPr lang="pt-BR" sz="1800" dirty="0" smtClean="0"/>
+              <a:t>Métodos </a:t>
+            </a:r>
+            <a:r>
+              <a:rPr lang="pt-BR" sz="1800" i="1" dirty="0" smtClean="0"/>
+              <a:t>get</a:t>
+            </a:r>
+            <a:r>
+              <a:rPr lang="pt-BR" sz="1800" dirty="0" smtClean="0"/>
+              <a:t> e </a:t>
+            </a:r>
+            <a:r>
+              <a:rPr lang="pt-BR" sz="1800" i="1" dirty="0" smtClean="0"/>
+              <a:t>set </a:t>
+            </a:r>
+            <a:r>
+              <a:rPr lang="pt-BR" sz="1800" dirty="0" smtClean="0"/>
+              <a:t>devem ser usados por outras classes para acessar os atributos</a:t>
+            </a:r>
+          </a:p>
+          <a:p>
+            <a:pPr lvl="1"/>
+            <a:endParaRPr lang="pt-BR" sz="1800" i="1" dirty="0"/>
+          </a:p>
+          <a:p>
+            <a:pPr lvl="1"/>
+            <a:endParaRPr lang="pt-BR" sz="1800" i="1" dirty="0"/>
           </a:p>
         </p:txBody>
       </p:sp>
@@ -9135,10 +9460,100 @@
           </a:p>
         </p:txBody>
       </p:sp>
+      <p:pic>
+        <p:nvPicPr>
+          <p:cNvPr id="5" name="Picture 4"/>
+          <p:cNvPicPr>
+            <a:picLocks noChangeAspect="1"/>
+          </p:cNvPicPr>
+          <p:nvPr/>
+        </p:nvPicPr>
+        <p:blipFill>
+          <a:blip r:embed="rId2">
+            <a:extLst>
+              <a:ext uri="{28A0092B-C50C-407E-A947-70E740481C1C}">
+                <a14:useLocalDpi xmlns:a14="http://schemas.microsoft.com/office/drawing/2010/main" val="0"/>
+              </a:ext>
+            </a:extLst>
+          </a:blip>
+          <a:stretch>
+            <a:fillRect/>
+          </a:stretch>
+        </p:blipFill>
+        <p:spPr>
+          <a:xfrm>
+            <a:off x="314455" y="2793477"/>
+            <a:ext cx="5936700" cy="2066540"/>
+          </a:xfrm>
+          <a:prstGeom prst="rect">
+            <a:avLst/>
+          </a:prstGeom>
+        </p:spPr>
+      </p:pic>
+      <p:pic>
+        <p:nvPicPr>
+          <p:cNvPr id="6" name="Picture 5"/>
+          <p:cNvPicPr>
+            <a:picLocks noChangeAspect="1"/>
+          </p:cNvPicPr>
+          <p:nvPr/>
+        </p:nvPicPr>
+        <p:blipFill>
+          <a:blip r:embed="rId3">
+            <a:extLst>
+              <a:ext uri="{28A0092B-C50C-407E-A947-70E740481C1C}">
+                <a14:useLocalDpi xmlns:a14="http://schemas.microsoft.com/office/drawing/2010/main" val="0"/>
+              </a:ext>
+            </a:extLst>
+          </a:blip>
+          <a:stretch>
+            <a:fillRect/>
+          </a:stretch>
+        </p:blipFill>
+        <p:spPr>
+          <a:xfrm>
+            <a:off x="5942181" y="1221746"/>
+            <a:ext cx="617948" cy="505053"/>
+          </a:xfrm>
+          <a:prstGeom prst="rect">
+            <a:avLst/>
+          </a:prstGeom>
+        </p:spPr>
+      </p:pic>
+      <p:pic>
+        <p:nvPicPr>
+          <p:cNvPr id="7" name="Picture 6"/>
+          <p:cNvPicPr>
+            <a:picLocks noChangeAspect="1"/>
+          </p:cNvPicPr>
+          <p:nvPr/>
+        </p:nvPicPr>
+        <p:blipFill>
+          <a:blip r:embed="rId4">
+            <a:extLst>
+              <a:ext uri="{28A0092B-C50C-407E-A947-70E740481C1C}">
+                <a14:useLocalDpi xmlns:a14="http://schemas.microsoft.com/office/drawing/2010/main" val="0"/>
+              </a:ext>
+            </a:extLst>
+          </a:blip>
+          <a:stretch>
+            <a:fillRect/>
+          </a:stretch>
+        </p:blipFill>
+        <p:spPr>
+          <a:xfrm>
+            <a:off x="2355245" y="2090359"/>
+            <a:ext cx="576675" cy="483308"/>
+          </a:xfrm>
+          <a:prstGeom prst="rect">
+            <a:avLst/>
+          </a:prstGeom>
+        </p:spPr>
+      </p:pic>
     </p:spTree>
     <p:extLst>
       <p:ext uri="{BB962C8B-B14F-4D97-AF65-F5344CB8AC3E}">
-        <p14:creationId xmlns:p14="http://schemas.microsoft.com/office/powerpoint/2010/main" val="1585876357"/>
+        <p14:creationId xmlns:p14="http://schemas.microsoft.com/office/powerpoint/2010/main" val="1945599809"/>
       </p:ext>
     </p:extLst>
   </p:cSld>
@@ -9177,7 +9592,7 @@
         </p:nvSpPr>
         <p:spPr>
           <a:xfrm>
-            <a:off x="311700" y="170054"/>
+            <a:off x="332482" y="216425"/>
             <a:ext cx="8520600" cy="572700"/>
           </a:xfrm>
         </p:spPr>
@@ -9188,7 +9603,7 @@
             <a:pPr algn="ctr"/>
             <a:r>
               <a:rPr lang="pt-BR" dirty="0" smtClean="0"/>
-              <a:t>Arquitetura de um SCV distribuído</a:t>
+              <a:t>Exemplo: Carro</a:t>
             </a:r>
             <a:endParaRPr lang="pt-BR" dirty="0"/>
           </a:p>
@@ -9228,7 +9643,7 @@
       </p:sp>
       <p:pic>
         <p:nvPicPr>
-          <p:cNvPr id="3" name="Picture 2"/>
+          <p:cNvPr id="5" name="Picture 4"/>
           <p:cNvPicPr>
             <a:picLocks noChangeAspect="1"/>
           </p:cNvPicPr>
@@ -9248,8 +9663,8 @@
         </p:blipFill>
         <p:spPr>
           <a:xfrm>
-            <a:off x="83128" y="1126079"/>
-            <a:ext cx="6311483" cy="3930738"/>
+            <a:off x="479488" y="880834"/>
+            <a:ext cx="6752585" cy="4104403"/>
           </a:xfrm>
           <a:prstGeom prst="rect">
             <a:avLst/>
@@ -9259,7 +9674,7 @@
     </p:spTree>
     <p:extLst>
       <p:ext uri="{BB962C8B-B14F-4D97-AF65-F5344CB8AC3E}">
-        <p14:creationId xmlns:p14="http://schemas.microsoft.com/office/powerpoint/2010/main" val="2599186345"/>
+        <p14:creationId xmlns:p14="http://schemas.microsoft.com/office/powerpoint/2010/main" val="595539683"/>
       </p:ext>
     </p:extLst>
   </p:cSld>

</xml_diff>